<commit_message>
feat: add initial macro plan for Triunfo do Brasil covering Aug/26 to Feb/27, focusing on market presence and budget allocation strategies
</commit_message>
<xml_diff>
--- a/Triunfo do Brasil/marketing/relatorios/triunfo-resultados-julho.pptx
+++ b/Triunfo do Brasil/marketing/relatorios/triunfo-resultados-julho.pptx
@@ -1354,6 +1354,13 @@
             <a:prstDash val="solid"/>
           </a:ln>
         </p:spPr>
+        <p:txBody>
+          <a:bodyPr/>
+          <a:lstStyle/>
+          <a:p>
+            <a:endParaRPr/>
+          </a:p>
+        </p:txBody>
       </p:sp>
       <p:sp>
         <p:nvSpPr>
@@ -1388,10 +1395,10 @@
                 <a:ea typeface="Calibri" pitchFamily="34" charset="-122"/>
                 <a:cs typeface="Calibri" pitchFamily="34" charset="-120"/>
               </a:rPr>
-              <a:t>Dados </a:t>
-            </a:r>
-            <a:r>
-              <a:rPr lang="en-US" sz="1200" dirty="0">
+              <a:t>Dados de plataforma: 01 a </a:t>
+            </a:r>
+            <a:r>
+              <a:rPr lang="en-US" sz="1200" dirty="0" smtClean="0">
                 <a:solidFill>
                   <a:srgbClr val="67836C"/>
                 </a:solidFill>
@@ -1399,7 +1406,18 @@
                 <a:ea typeface="Calibri" pitchFamily="34" charset="-122"/>
                 <a:cs typeface="Calibri" pitchFamily="34" charset="-120"/>
               </a:rPr>
-              <a:t>de plataforma: 01 a 14/07/2026  •  Leads consolidados até 13/07/2026</a:t>
+              <a:t>21/07/2026  </a:t>
+            </a:r>
+            <a:r>
+              <a:rPr lang="en-US" sz="1200" dirty="0" smtClean="0">
+                <a:solidFill>
+                  <a:srgbClr val="67836C"/>
+                </a:solidFill>
+                <a:latin typeface="Calibri" pitchFamily="34" charset="0"/>
+                <a:ea typeface="Calibri" pitchFamily="34" charset="-122"/>
+                <a:cs typeface="Calibri" pitchFamily="34" charset="-120"/>
+              </a:rPr>
+              <a:t>•  Leads consolidados até 21/07/2026</a:t>
             </a:r>
             <a:endParaRPr lang="en-US" sz="1200" dirty="0"/>
           </a:p>
@@ -1919,6 +1937,13 @@
             <a:prstDash val="solid"/>
           </a:ln>
         </p:spPr>
+        <p:txBody>
+          <a:bodyPr/>
+          <a:lstStyle/>
+          <a:p>
+            <a:endParaRPr/>
+          </a:p>
+        </p:txBody>
       </p:sp>
       <p:sp>
         <p:nvSpPr>
@@ -1945,7 +1970,7 @@
               <a:buNone/>
             </a:pPr>
             <a:r>
-              <a:rPr lang="en-US" sz="2800" b="1" dirty="0">
+              <a:rPr lang="en-US" sz="2800" b="1" dirty="0" smtClean="0">
                 <a:solidFill>
                   <a:srgbClr val="132E14"/>
                 </a:solidFill>
@@ -1953,7 +1978,7 @@
                 <a:ea typeface="Arial" pitchFamily="34" charset="-122"/>
                 <a:cs typeface="Arial" pitchFamily="34" charset="-120"/>
               </a:rPr>
-              <a:t>40</a:t>
+              <a:t>45</a:t>
             </a:r>
             <a:endParaRPr lang="en-US" sz="2800" dirty="0"/>
           </a:p>
@@ -1992,7 +2017,7 @@
                 <a:ea typeface="Calibri" pitchFamily="34" charset="-122"/>
                 <a:cs typeface="Calibri" pitchFamily="34" charset="-120"/>
               </a:rPr>
-              <a:t>leads registrados em 13 dias</a:t>
+              <a:t>leads registrados em 21 dias</a:t>
             </a:r>
             <a:endParaRPr lang="en-US" sz="1050" dirty="0"/>
           </a:p>
@@ -2001,7 +2026,7 @@
               <a:buNone/>
             </a:pPr>
             <a:r>
-              <a:rPr lang="en-US" sz="1050" dirty="0">
+              <a:rPr lang="en-US" sz="1050" dirty="0" smtClean="0">
                 <a:solidFill>
                   <a:srgbClr val="6E7B70"/>
                 </a:solidFill>
@@ -2009,7 +2034,7 @@
                 <a:ea typeface="Calibri" pitchFamily="34" charset="-122"/>
                 <a:cs typeface="Calibri" pitchFamily="34" charset="-120"/>
               </a:rPr>
-              <a:t>(33 vindos de mídia paga)</a:t>
+              <a:t>(54 leads no total)</a:t>
             </a:r>
             <a:endParaRPr lang="en-US" sz="1050" dirty="0"/>
           </a:p>
@@ -2041,6 +2066,13 @@
             <a:prstDash val="solid"/>
           </a:ln>
         </p:spPr>
+        <p:txBody>
+          <a:bodyPr/>
+          <a:lstStyle/>
+          <a:p>
+            <a:endParaRPr/>
+          </a:p>
+        </p:txBody>
       </p:sp>
       <p:sp>
         <p:nvSpPr>
@@ -2075,7 +2107,7 @@
                 <a:ea typeface="Arial" pitchFamily="34" charset="-122"/>
                 <a:cs typeface="Arial" pitchFamily="34" charset="-120"/>
               </a:rPr>
-              <a:t>R$ 4.112</a:t>
+              <a:t>R$ 5.434</a:t>
             </a:r>
             <a:endParaRPr lang="en-US" sz="2800" dirty="0"/>
           </a:p>
@@ -2163,6 +2195,13 @@
             <a:prstDash val="solid"/>
           </a:ln>
         </p:spPr>
+        <p:txBody>
+          <a:bodyPr/>
+          <a:lstStyle/>
+          <a:p>
+            <a:endParaRPr/>
+          </a:p>
+        </p:txBody>
       </p:sp>
       <p:sp>
         <p:nvSpPr>
@@ -2197,7 +2236,7 @@
                 <a:ea typeface="Arial" pitchFamily="34" charset="-122"/>
                 <a:cs typeface="Arial" pitchFamily="34" charset="-120"/>
               </a:rPr>
-              <a:t>R$ 57</a:t>
+              <a:t>R$ 56</a:t>
             </a:r>
             <a:endParaRPr lang="en-US" sz="2800" dirty="0"/>
           </a:p>
@@ -2285,6 +2324,13 @@
             <a:prstDash val="solid"/>
           </a:ln>
         </p:spPr>
+        <p:txBody>
+          <a:bodyPr/>
+          <a:lstStyle/>
+          <a:p>
+            <a:endParaRPr/>
+          </a:p>
+        </p:txBody>
       </p:sp>
       <p:sp>
         <p:nvSpPr>
@@ -2429,6 +2475,13 @@
             <a:prstDash val="solid"/>
           </a:ln>
         </p:spPr>
+        <p:txBody>
+          <a:bodyPr/>
+          <a:lstStyle/>
+          <a:p>
+            <a:endParaRPr/>
+          </a:p>
+        </p:txBody>
       </p:sp>
       <p:sp>
         <p:nvSpPr>
@@ -2466,7 +2519,7 @@
                 <a:ea typeface="Calibri" pitchFamily="34" charset="-122"/>
                 <a:cs typeface="Calibri" pitchFamily="34" charset="-120"/>
               </a:rPr>
-              <a:t>O volume deixou de ser o </a:t>
+              <a:t>O volume deixou de ser o problema: em 21 dias entraram mais leads do que em qualquer mês do histórico da conta. A </a:t>
             </a:r>
             <a:r>
               <a:rPr lang="en-US" sz="1300" dirty="0" err="1" smtClean="0">
@@ -2477,7 +2530,7 @@
                 <a:ea typeface="Calibri" pitchFamily="34" charset="-122"/>
                 <a:cs typeface="Calibri" pitchFamily="34" charset="-120"/>
               </a:rPr>
-              <a:t>problema</a:t>
+              <a:t>melhoria</a:t>
             </a:r>
             <a:r>
               <a:rPr lang="en-US" sz="1300" dirty="0" smtClean="0">
@@ -2488,10 +2541,10 @@
                 <a:ea typeface="Calibri" pitchFamily="34" charset="-122"/>
                 <a:cs typeface="Calibri" pitchFamily="34" charset="-120"/>
               </a:rPr>
-              <a:t>: </a:t>
-            </a:r>
-            <a:r>
-              <a:rPr lang="en-US" sz="1300" b="1" dirty="0" err="1" smtClean="0">
+              <a:t>, </a:t>
+            </a:r>
+            <a:r>
+              <a:rPr lang="en-US" sz="1300" dirty="0" err="1" smtClean="0">
                 <a:solidFill>
                   <a:srgbClr val="FFFFFF"/>
                 </a:solidFill>
@@ -2499,10 +2552,10 @@
                 <a:ea typeface="Calibri" pitchFamily="34" charset="-122"/>
                 <a:cs typeface="Calibri" pitchFamily="34" charset="-120"/>
               </a:rPr>
-              <a:t>em</a:t>
-            </a:r>
-            <a:r>
-              <a:rPr lang="en-US" sz="1300" b="1" dirty="0" smtClean="0">
+              <a:t>então</a:t>
+            </a:r>
+            <a:r>
+              <a:rPr lang="en-US" sz="1300" dirty="0" smtClean="0">
                 <a:solidFill>
                   <a:srgbClr val="FFFFFF"/>
                 </a:solidFill>
@@ -2510,10 +2563,32 @@
                 <a:ea typeface="Calibri" pitchFamily="34" charset="-122"/>
                 <a:cs typeface="Calibri" pitchFamily="34" charset="-120"/>
               </a:rPr>
+              <a:t>, </a:t>
+            </a:r>
+            <a:r>
+              <a:rPr lang="en-US" sz="1300" dirty="0" err="1" smtClean="0">
+                <a:solidFill>
+                  <a:srgbClr val="FFFFFF"/>
+                </a:solidFill>
+                <a:latin typeface="Calibri" pitchFamily="34" charset="0"/>
+                <a:ea typeface="Calibri" pitchFamily="34" charset="-122"/>
+                <a:cs typeface="Calibri" pitchFamily="34" charset="-120"/>
+              </a:rPr>
+              <a:t>foi</a:t>
+            </a:r>
+            <a:r>
+              <a:rPr lang="en-US" sz="1300" dirty="0" smtClean="0">
+                <a:solidFill>
+                  <a:srgbClr val="FFFFFF"/>
+                </a:solidFill>
+                <a:latin typeface="Calibri" pitchFamily="34" charset="0"/>
+                <a:ea typeface="Calibri" pitchFamily="34" charset="-122"/>
+                <a:cs typeface="Calibri" pitchFamily="34" charset="-120"/>
+              </a:rPr>
               <a:t> </a:t>
             </a:r>
             <a:r>
-              <a:rPr lang="en-US" sz="1300" b="1" dirty="0">
+              <a:rPr lang="en-US" sz="1300" dirty="0">
                 <a:solidFill>
                   <a:srgbClr val="FFFFFF"/>
                 </a:solidFill>
@@ -2521,7 +2596,18 @@
                 <a:ea typeface="Calibri" pitchFamily="34" charset="-122"/>
                 <a:cs typeface="Calibri" pitchFamily="34" charset="-120"/>
               </a:rPr>
-              <a:t>13 dias entraram mais leads do que em qualquer mês do histórico da conta</a:t>
+              <a:t>fit: a maior parte dos contatos ainda </a:t>
+            </a:r>
+            <a:r>
+              <a:rPr lang="en-US" sz="1300" dirty="0" err="1">
+                <a:solidFill>
+                  <a:srgbClr val="FFFFFF"/>
+                </a:solidFill>
+                <a:latin typeface="Calibri" pitchFamily="34" charset="0"/>
+                <a:ea typeface="Calibri" pitchFamily="34" charset="-122"/>
+                <a:cs typeface="Calibri" pitchFamily="34" charset="-120"/>
+              </a:rPr>
+              <a:t>não</a:t>
             </a:r>
             <a:r>
               <a:rPr lang="en-US" sz="1300" dirty="0">
@@ -2532,7 +2618,7 @@
                 <a:ea typeface="Calibri" pitchFamily="34" charset="-122"/>
                 <a:cs typeface="Calibri" pitchFamily="34" charset="-120"/>
               </a:rPr>
-              <a:t>. </a:t>
+              <a:t> </a:t>
             </a:r>
             <a:r>
               <a:rPr lang="en-US" sz="1300" dirty="0" smtClean="0">
@@ -2543,7 +2629,40 @@
                 <a:ea typeface="Calibri" pitchFamily="34" charset="-122"/>
                 <a:cs typeface="Calibri" pitchFamily="34" charset="-120"/>
               </a:rPr>
-              <a:t>A </a:t>
+              <a:t>era </a:t>
+            </a:r>
+            <a:r>
+              <a:rPr lang="en-US" sz="1300" dirty="0">
+                <a:solidFill>
+                  <a:srgbClr val="FFFFFF"/>
+                </a:solidFill>
+                <a:latin typeface="Calibri" pitchFamily="34" charset="0"/>
+                <a:ea typeface="Calibri" pitchFamily="34" charset="-122"/>
+                <a:cs typeface="Calibri" pitchFamily="34" charset="-120"/>
+              </a:rPr>
+              <a:t>comprador industrial. Isso já foi identificado e já </a:t>
+            </a:r>
+            <a:r>
+              <a:rPr lang="en-US" sz="1300" dirty="0" err="1">
+                <a:solidFill>
+                  <a:srgbClr val="FFFFFF"/>
+                </a:solidFill>
+                <a:latin typeface="Calibri" pitchFamily="34" charset="0"/>
+                <a:ea typeface="Calibri" pitchFamily="34" charset="-122"/>
+                <a:cs typeface="Calibri" pitchFamily="34" charset="-120"/>
+              </a:rPr>
+              <a:t>gerou</a:t>
+            </a:r>
+            <a:r>
+              <a:rPr lang="en-US" sz="1300" dirty="0">
+                <a:solidFill>
+                  <a:srgbClr val="FFFFFF"/>
+                </a:solidFill>
+                <a:latin typeface="Calibri" pitchFamily="34" charset="0"/>
+                <a:ea typeface="Calibri" pitchFamily="34" charset="-122"/>
+                <a:cs typeface="Calibri" pitchFamily="34" charset="-120"/>
+              </a:rPr>
+              <a:t> </a:t>
             </a:r>
             <a:r>
               <a:rPr lang="en-US" sz="1300" dirty="0" err="1" smtClean="0">
@@ -2554,7 +2673,7 @@
                 <a:ea typeface="Calibri" pitchFamily="34" charset="-122"/>
                 <a:cs typeface="Calibri" pitchFamily="34" charset="-120"/>
               </a:rPr>
-              <a:t>melhoria</a:t>
+              <a:t>correção</a:t>
             </a:r>
             <a:r>
               <a:rPr lang="en-US" sz="1300" dirty="0" smtClean="0">
@@ -2565,7 +2684,7 @@
                 <a:ea typeface="Calibri" pitchFamily="34" charset="-122"/>
                 <a:cs typeface="Calibri" pitchFamily="34" charset="-120"/>
               </a:rPr>
-              <a:t> agora </a:t>
+              <a:t>, o </a:t>
             </a:r>
             <a:r>
               <a:rPr lang="en-US" sz="1300" dirty="0">
@@ -2576,161 +2695,7 @@
                 <a:ea typeface="Calibri" pitchFamily="34" charset="-122"/>
                 <a:cs typeface="Calibri" pitchFamily="34" charset="-120"/>
               </a:rPr>
-              <a:t>é </a:t>
-            </a:r>
-            <a:r>
-              <a:rPr lang="en-US" sz="1300" dirty="0" smtClean="0">
-                <a:solidFill>
-                  <a:srgbClr val="FFFFFF"/>
-                </a:solidFill>
-                <a:latin typeface="Calibri" pitchFamily="34" charset="0"/>
-                <a:ea typeface="Calibri" pitchFamily="34" charset="-122"/>
-                <a:cs typeface="Calibri" pitchFamily="34" charset="-120"/>
-              </a:rPr>
-              <a:t>fit: </a:t>
-            </a:r>
-            <a:r>
-              <a:rPr lang="en-US" sz="1300" dirty="0">
-                <a:solidFill>
-                  <a:srgbClr val="FFFFFF"/>
-                </a:solidFill>
-                <a:latin typeface="Calibri" pitchFamily="34" charset="0"/>
-                <a:ea typeface="Calibri" pitchFamily="34" charset="-122"/>
-                <a:cs typeface="Calibri" pitchFamily="34" charset="-120"/>
-              </a:rPr>
-              <a:t>a maior parte dos contatos ainda não é comprador industrial. Isso já foi identificado e já </a:t>
-            </a:r>
-            <a:r>
-              <a:rPr lang="en-US" sz="1300" dirty="0" err="1">
-                <a:solidFill>
-                  <a:srgbClr val="FFFFFF"/>
-                </a:solidFill>
-                <a:latin typeface="Calibri" pitchFamily="34" charset="0"/>
-                <a:ea typeface="Calibri" pitchFamily="34" charset="-122"/>
-                <a:cs typeface="Calibri" pitchFamily="34" charset="-120"/>
-              </a:rPr>
-              <a:t>gerou</a:t>
-            </a:r>
-            <a:r>
-              <a:rPr lang="en-US" sz="1300" dirty="0">
-                <a:solidFill>
-                  <a:srgbClr val="FFFFFF"/>
-                </a:solidFill>
-                <a:latin typeface="Calibri" pitchFamily="34" charset="0"/>
-                <a:ea typeface="Calibri" pitchFamily="34" charset="-122"/>
-                <a:cs typeface="Calibri" pitchFamily="34" charset="-120"/>
-              </a:rPr>
-              <a:t> </a:t>
-            </a:r>
-            <a:r>
-              <a:rPr lang="en-US" sz="1300" dirty="0" err="1" smtClean="0">
-                <a:solidFill>
-                  <a:srgbClr val="FFFFFF"/>
-                </a:solidFill>
-                <a:latin typeface="Calibri" pitchFamily="34" charset="0"/>
-                <a:ea typeface="Calibri" pitchFamily="34" charset="-122"/>
-                <a:cs typeface="Calibri" pitchFamily="34" charset="-120"/>
-              </a:rPr>
-              <a:t>correção</a:t>
-            </a:r>
-            <a:r>
-              <a:rPr lang="en-US" sz="1300" dirty="0" smtClean="0">
-                <a:solidFill>
-                  <a:srgbClr val="FFFFFF"/>
-                </a:solidFill>
-                <a:latin typeface="Calibri" pitchFamily="34" charset="0"/>
-                <a:ea typeface="Calibri" pitchFamily="34" charset="-122"/>
-                <a:cs typeface="Calibri" pitchFamily="34" charset="-120"/>
-              </a:rPr>
-              <a:t>. O </a:t>
-            </a:r>
-            <a:r>
-              <a:rPr lang="en-US" sz="1300" dirty="0">
-                <a:solidFill>
-                  <a:srgbClr val="FFFFFF"/>
-                </a:solidFill>
-                <a:latin typeface="Calibri" pitchFamily="34" charset="0"/>
-                <a:ea typeface="Calibri" pitchFamily="34" charset="-122"/>
-                <a:cs typeface="Calibri" pitchFamily="34" charset="-120"/>
-              </a:rPr>
-              <a:t>zero acima significa "ainda não avaliado", não "lead ruim": </a:t>
-            </a:r>
-            <a:r>
-              <a:rPr lang="en-US" sz="1300" dirty="0" err="1" smtClean="0">
-                <a:solidFill>
-                  <a:srgbClr val="FFFFFF"/>
-                </a:solidFill>
-                <a:latin typeface="Calibri" pitchFamily="34" charset="0"/>
-                <a:ea typeface="Calibri" pitchFamily="34" charset="-122"/>
-                <a:cs typeface="Calibri" pitchFamily="34" charset="-120"/>
-              </a:rPr>
-              <a:t>maioria</a:t>
-            </a:r>
-            <a:r>
-              <a:rPr lang="en-US" sz="1300" dirty="0" smtClean="0">
-                <a:solidFill>
-                  <a:srgbClr val="FFFFFF"/>
-                </a:solidFill>
-                <a:latin typeface="Calibri" pitchFamily="34" charset="0"/>
-                <a:ea typeface="Calibri" pitchFamily="34" charset="-122"/>
-                <a:cs typeface="Calibri" pitchFamily="34" charset="-120"/>
-              </a:rPr>
-              <a:t> dos leads </a:t>
-            </a:r>
-            <a:r>
-              <a:rPr lang="en-US" sz="1300" dirty="0" err="1" smtClean="0">
-                <a:solidFill>
-                  <a:srgbClr val="FFFFFF"/>
-                </a:solidFill>
-                <a:latin typeface="Calibri" pitchFamily="34" charset="0"/>
-                <a:ea typeface="Calibri" pitchFamily="34" charset="-122"/>
-                <a:cs typeface="Calibri" pitchFamily="34" charset="-120"/>
-              </a:rPr>
-              <a:t>ainda</a:t>
-            </a:r>
-            <a:r>
-              <a:rPr lang="en-US" sz="1300" dirty="0" smtClean="0">
-                <a:solidFill>
-                  <a:srgbClr val="FFFFFF"/>
-                </a:solidFill>
-                <a:latin typeface="Calibri" pitchFamily="34" charset="0"/>
-                <a:ea typeface="Calibri" pitchFamily="34" charset="-122"/>
-                <a:cs typeface="Calibri" pitchFamily="34" charset="-120"/>
-              </a:rPr>
-              <a:t> </a:t>
-            </a:r>
-            <a:r>
-              <a:rPr lang="en-US" sz="1300" dirty="0" err="1" smtClean="0">
-                <a:solidFill>
-                  <a:srgbClr val="FFFFFF"/>
-                </a:solidFill>
-                <a:latin typeface="Calibri" pitchFamily="34" charset="0"/>
-                <a:ea typeface="Calibri" pitchFamily="34" charset="-122"/>
-                <a:cs typeface="Calibri" pitchFamily="34" charset="-120"/>
-              </a:rPr>
-              <a:t>não</a:t>
-            </a:r>
-            <a:r>
-              <a:rPr lang="en-US" sz="1300" dirty="0" smtClean="0">
-                <a:solidFill>
-                  <a:srgbClr val="FFFFFF"/>
-                </a:solidFill>
-                <a:latin typeface="Calibri" pitchFamily="34" charset="0"/>
-                <a:ea typeface="Calibri" pitchFamily="34" charset="-122"/>
-                <a:cs typeface="Calibri" pitchFamily="34" charset="-120"/>
-              </a:rPr>
-              <a:t> </a:t>
-            </a:r>
-            <a:r>
-              <a:rPr lang="en-US" sz="1300" dirty="0">
-                <a:solidFill>
-                  <a:srgbClr val="FFFFFF"/>
-                </a:solidFill>
-                <a:latin typeface="Calibri" pitchFamily="34" charset="0"/>
-                <a:ea typeface="Calibri" pitchFamily="34" charset="-122"/>
-                <a:cs typeface="Calibri" pitchFamily="34" charset="-120"/>
-              </a:rPr>
-              <a:t>passou pela etapa de qualificação, e o ciclo de venda deste mercado é medido em meses.</a:t>
+              <a:t>formulário V3, no ar desde 14/07, com a primeira leitura no slide de perfil. O zero acima significa "ainda não avaliado", não "lead ruim": a maioria dos leads ainda não passou pela etapa de qualificação, e o ciclo de venda deste mercado é medido em meses.</a:t>
             </a:r>
             <a:endParaRPr lang="en-US" sz="1300" dirty="0"/>
           </a:p>
@@ -2965,10 +2930,32 @@
                 <a:ea typeface="Calibri" pitchFamily="34" charset="-122"/>
                 <a:cs typeface="Calibri" pitchFamily="34" charset="-120"/>
               </a:rPr>
+              <a:t> dos leads: V3 no </a:t>
+            </a:r>
+            <a:r>
+              <a:rPr lang="en-US" sz="1200" dirty="0" err="1" smtClean="0">
+                <a:solidFill>
+                  <a:srgbClr val="2B332C"/>
+                </a:solidFill>
+                <a:latin typeface="Calibri" pitchFamily="34" charset="0"/>
+                <a:ea typeface="Calibri" pitchFamily="34" charset="-122"/>
+                <a:cs typeface="Calibri" pitchFamily="34" charset="-120"/>
+              </a:rPr>
+              <a:t>ar</a:t>
+            </a:r>
+            <a:r>
+              <a:rPr lang="en-US" sz="1200" dirty="0" smtClean="0">
+                <a:solidFill>
+                  <a:srgbClr val="2B332C"/>
+                </a:solidFill>
+                <a:latin typeface="Calibri" pitchFamily="34" charset="0"/>
+                <a:ea typeface="Calibri" pitchFamily="34" charset="-122"/>
+                <a:cs typeface="Calibri" pitchFamily="34" charset="-120"/>
+              </a:rPr>
               <a:t> </a:t>
             </a:r>
             <a:r>
-              <a:rPr lang="en-US" sz="1200" dirty="0">
+              <a:rPr lang="en-US" sz="1200" dirty="0" err="1" smtClean="0">
                 <a:solidFill>
                   <a:srgbClr val="2B332C"/>
                 </a:solidFill>
@@ -2976,10 +2963,10 @@
                 <a:ea typeface="Calibri" pitchFamily="34" charset="-122"/>
                 <a:cs typeface="Calibri" pitchFamily="34" charset="-120"/>
               </a:rPr>
-              <a:t>dos leads: </a:t>
-            </a:r>
-            <a:r>
-              <a:rPr lang="en-US" sz="1200" dirty="0" err="1">
+              <a:t>há</a:t>
+            </a:r>
+            <a:r>
+              <a:rPr lang="en-US" sz="1200" dirty="0" smtClean="0">
                 <a:solidFill>
                   <a:srgbClr val="2B332C"/>
                 </a:solidFill>
@@ -2987,10 +2974,10 @@
                 <a:ea typeface="Calibri" pitchFamily="34" charset="-122"/>
                 <a:cs typeface="Calibri" pitchFamily="34" charset="-120"/>
               </a:rPr>
-              <a:t>formulário</a:t>
-            </a:r>
-            <a:r>
-              <a:rPr lang="en-US" sz="1200" dirty="0">
+              <a:t> 8 </a:t>
+            </a:r>
+            <a:r>
+              <a:rPr lang="en-US" sz="1200" dirty="0" err="1" smtClean="0">
                 <a:solidFill>
                   <a:srgbClr val="2B332C"/>
                 </a:solidFill>
@@ -2998,6 +2985,17 @@
                 <a:ea typeface="Calibri" pitchFamily="34" charset="-122"/>
                 <a:cs typeface="Calibri" pitchFamily="34" charset="-120"/>
               </a:rPr>
+              <a:t>dias</a:t>
+            </a:r>
+            <a:r>
+              <a:rPr lang="en-US" sz="1200" dirty="0" smtClean="0">
+                <a:solidFill>
+                  <a:srgbClr val="2B332C"/>
+                </a:solidFill>
+                <a:latin typeface="Calibri" pitchFamily="34" charset="0"/>
+                <a:ea typeface="Calibri" pitchFamily="34" charset="-122"/>
+                <a:cs typeface="Calibri" pitchFamily="34" charset="-120"/>
+              </a:rPr>
               <a:t> </a:t>
             </a:r>
             <a:r>
@@ -3009,10 +3007,10 @@
                 <a:ea typeface="Calibri" pitchFamily="34" charset="-122"/>
                 <a:cs typeface="Calibri" pitchFamily="34" charset="-120"/>
               </a:rPr>
-              <a:t>V3 (Meta) </a:t>
-            </a:r>
-            <a:r>
-              <a:rPr lang="en-US" sz="1200" dirty="0">
+              <a:t>— </a:t>
+            </a:r>
+            <a:r>
+              <a:rPr lang="en-US" sz="1200" dirty="0" err="1" smtClean="0">
                 <a:solidFill>
                   <a:srgbClr val="2B332C"/>
                 </a:solidFill>
@@ -3020,7 +3018,73 @@
                 <a:ea typeface="Calibri" pitchFamily="34" charset="-122"/>
                 <a:cs typeface="Calibri" pitchFamily="34" charset="-120"/>
               </a:rPr>
-              <a:t>em teste por 14 dias</a:t>
+              <a:t>primeira</a:t>
+            </a:r>
+            <a:r>
+              <a:rPr lang="en-US" sz="1200" dirty="0" smtClean="0">
+                <a:solidFill>
+                  <a:srgbClr val="2B332C"/>
+                </a:solidFill>
+                <a:latin typeface="Calibri" pitchFamily="34" charset="0"/>
+                <a:ea typeface="Calibri" pitchFamily="34" charset="-122"/>
+                <a:cs typeface="Calibri" pitchFamily="34" charset="-120"/>
+              </a:rPr>
+              <a:t> </a:t>
+            </a:r>
+            <a:r>
+              <a:rPr lang="en-US" sz="1200" dirty="0" err="1" smtClean="0">
+                <a:solidFill>
+                  <a:srgbClr val="2B332C"/>
+                </a:solidFill>
+                <a:latin typeface="Calibri" pitchFamily="34" charset="0"/>
+                <a:ea typeface="Calibri" pitchFamily="34" charset="-122"/>
+                <a:cs typeface="Calibri" pitchFamily="34" charset="-120"/>
+              </a:rPr>
+              <a:t>leitura</a:t>
+            </a:r>
+            <a:r>
+              <a:rPr lang="en-US" sz="1200" dirty="0" smtClean="0">
+                <a:solidFill>
+                  <a:srgbClr val="2B332C"/>
+                </a:solidFill>
+                <a:latin typeface="Calibri" pitchFamily="34" charset="0"/>
+                <a:ea typeface="Calibri" pitchFamily="34" charset="-122"/>
+                <a:cs typeface="Calibri" pitchFamily="34" charset="-120"/>
+              </a:rPr>
+              <a:t> </a:t>
+            </a:r>
+            <a:r>
+              <a:rPr lang="en-US" sz="1200" dirty="0" err="1" smtClean="0">
+                <a:solidFill>
+                  <a:srgbClr val="2B332C"/>
+                </a:solidFill>
+                <a:latin typeface="Calibri" pitchFamily="34" charset="0"/>
+                <a:ea typeface="Calibri" pitchFamily="34" charset="-122"/>
+                <a:cs typeface="Calibri" pitchFamily="34" charset="-120"/>
+              </a:rPr>
+              <a:t>já</a:t>
+            </a:r>
+            <a:r>
+              <a:rPr lang="en-US" sz="1200" dirty="0" smtClean="0">
+                <a:solidFill>
+                  <a:srgbClr val="2B332C"/>
+                </a:solidFill>
+                <a:latin typeface="Calibri" pitchFamily="34" charset="0"/>
+                <a:ea typeface="Calibri" pitchFamily="34" charset="-122"/>
+                <a:cs typeface="Calibri" pitchFamily="34" charset="-120"/>
+              </a:rPr>
+              <a:t> </a:t>
+            </a:r>
+            <a:r>
+              <a:rPr lang="en-US" sz="1200" dirty="0" err="1" smtClean="0">
+                <a:solidFill>
+                  <a:srgbClr val="2B332C"/>
+                </a:solidFill>
+                <a:latin typeface="Calibri" pitchFamily="34" charset="0"/>
+                <a:ea typeface="Calibri" pitchFamily="34" charset="-122"/>
+                <a:cs typeface="Calibri" pitchFamily="34" charset="-120"/>
+              </a:rPr>
+              <a:t>disponível</a:t>
             </a:r>
             <a:endParaRPr lang="en-US" sz="1300" dirty="0"/>
           </a:p>
@@ -3995,7 +4059,194 @@
                 <a:ea typeface="Calibri" pitchFamily="34" charset="-122"/>
                 <a:cs typeface="Calibri" pitchFamily="34" charset="-120"/>
               </a:rPr>
-              <a:t>leads. A decisão foi reativar a captação primeiro e instrumentar em seguida, em vez de manter a operação parada esperando a instrumentação completa. Foi uma escolha de sequência, e funcionou: os leads voltaram e nenhum se perdeu, porque a planilha cobre a lacuna.</a:t>
+              <a:t>leads. A decisão foi reativar a </a:t>
+            </a:r>
+            <a:r>
+              <a:rPr lang="en-US" sz="1150" dirty="0" err="1" smtClean="0">
+                <a:solidFill>
+                  <a:srgbClr val="FFFFFF"/>
+                </a:solidFill>
+                <a:latin typeface="Calibri" pitchFamily="34" charset="0"/>
+                <a:ea typeface="Calibri" pitchFamily="34" charset="-122"/>
+                <a:cs typeface="Calibri" pitchFamily="34" charset="-120"/>
+              </a:rPr>
+              <a:t>captação</a:t>
+            </a:r>
+            <a:r>
+              <a:rPr lang="en-US" sz="1150" dirty="0" smtClean="0">
+                <a:solidFill>
+                  <a:srgbClr val="FFFFFF"/>
+                </a:solidFill>
+                <a:latin typeface="Calibri" pitchFamily="34" charset="0"/>
+                <a:ea typeface="Calibri" pitchFamily="34" charset="-122"/>
+                <a:cs typeface="Calibri" pitchFamily="34" charset="-120"/>
+              </a:rPr>
+              <a:t> de volume </a:t>
+            </a:r>
+            <a:r>
+              <a:rPr lang="en-US" sz="1150" dirty="0">
+                <a:solidFill>
+                  <a:srgbClr val="FFFFFF"/>
+                </a:solidFill>
+                <a:latin typeface="Calibri" pitchFamily="34" charset="0"/>
+                <a:ea typeface="Calibri" pitchFamily="34" charset="-122"/>
+                <a:cs typeface="Calibri" pitchFamily="34" charset="-120"/>
+              </a:rPr>
+              <a:t>primeiro e instrumentar </a:t>
+            </a:r>
+            <a:r>
+              <a:rPr lang="en-US" sz="1150" dirty="0" err="1">
+                <a:solidFill>
+                  <a:srgbClr val="FFFFFF"/>
+                </a:solidFill>
+                <a:latin typeface="Calibri" pitchFamily="34" charset="0"/>
+                <a:ea typeface="Calibri" pitchFamily="34" charset="-122"/>
+                <a:cs typeface="Calibri" pitchFamily="34" charset="-120"/>
+              </a:rPr>
+              <a:t>em</a:t>
+            </a:r>
+            <a:r>
+              <a:rPr lang="en-US" sz="1150" dirty="0">
+                <a:solidFill>
+                  <a:srgbClr val="FFFFFF"/>
+                </a:solidFill>
+                <a:latin typeface="Calibri" pitchFamily="34" charset="0"/>
+                <a:ea typeface="Calibri" pitchFamily="34" charset="-122"/>
+                <a:cs typeface="Calibri" pitchFamily="34" charset="-120"/>
+              </a:rPr>
+              <a:t> </a:t>
+            </a:r>
+            <a:r>
+              <a:rPr lang="en-US" sz="1150" dirty="0" err="1" smtClean="0">
+                <a:solidFill>
+                  <a:srgbClr val="FFFFFF"/>
+                </a:solidFill>
+                <a:latin typeface="Calibri" pitchFamily="34" charset="0"/>
+                <a:ea typeface="Calibri" pitchFamily="34" charset="-122"/>
+                <a:cs typeface="Calibri" pitchFamily="34" charset="-120"/>
+              </a:rPr>
+              <a:t>seguida</a:t>
+            </a:r>
+            <a:r>
+              <a:rPr lang="en-US" sz="1150" dirty="0" smtClean="0">
+                <a:solidFill>
+                  <a:srgbClr val="FFFFFF"/>
+                </a:solidFill>
+                <a:latin typeface="Calibri" pitchFamily="34" charset="0"/>
+                <a:ea typeface="Calibri" pitchFamily="34" charset="-122"/>
+                <a:cs typeface="Calibri" pitchFamily="34" charset="-120"/>
+              </a:rPr>
+              <a:t>. </a:t>
+            </a:r>
+            <a:r>
+              <a:rPr lang="en-US" sz="1150" dirty="0">
+                <a:solidFill>
+                  <a:srgbClr val="FFFFFF"/>
+                </a:solidFill>
+                <a:latin typeface="Calibri" pitchFamily="34" charset="0"/>
+                <a:ea typeface="Calibri" pitchFamily="34" charset="-122"/>
+                <a:cs typeface="Calibri" pitchFamily="34" charset="-120"/>
+              </a:rPr>
+              <a:t>Foi uma escolha de sequência, e funcionou: os leads voltaram e nenhum se perdeu, porque a planilha cobre a </a:t>
+            </a:r>
+            <a:r>
+              <a:rPr lang="en-US" sz="1150" dirty="0" smtClean="0">
+                <a:solidFill>
+                  <a:srgbClr val="FFFFFF"/>
+                </a:solidFill>
+                <a:latin typeface="Calibri" pitchFamily="34" charset="0"/>
+                <a:ea typeface="Calibri" pitchFamily="34" charset="-122"/>
+                <a:cs typeface="Calibri" pitchFamily="34" charset="-120"/>
+              </a:rPr>
+              <a:t>lacuna que o </a:t>
+            </a:r>
+            <a:r>
+              <a:rPr lang="en-US" sz="1150" dirty="0" err="1" smtClean="0">
+                <a:solidFill>
+                  <a:srgbClr val="FFFFFF"/>
+                </a:solidFill>
+                <a:latin typeface="Calibri" pitchFamily="34" charset="0"/>
+                <a:ea typeface="Calibri" pitchFamily="34" charset="-122"/>
+                <a:cs typeface="Calibri" pitchFamily="34" charset="-120"/>
+              </a:rPr>
+              <a:t>traqueamento</a:t>
+            </a:r>
+            <a:r>
+              <a:rPr lang="en-US" sz="1150" dirty="0" smtClean="0">
+                <a:solidFill>
+                  <a:srgbClr val="FFFFFF"/>
+                </a:solidFill>
+                <a:latin typeface="Calibri" pitchFamily="34" charset="0"/>
+                <a:ea typeface="Calibri" pitchFamily="34" charset="-122"/>
+                <a:cs typeface="Calibri" pitchFamily="34" charset="-120"/>
+              </a:rPr>
+              <a:t> </a:t>
+            </a:r>
+            <a:r>
+              <a:rPr lang="en-US" sz="1150" dirty="0" err="1" smtClean="0">
+                <a:solidFill>
+                  <a:srgbClr val="FFFFFF"/>
+                </a:solidFill>
+                <a:latin typeface="Calibri" pitchFamily="34" charset="0"/>
+                <a:ea typeface="Calibri" pitchFamily="34" charset="-122"/>
+                <a:cs typeface="Calibri" pitchFamily="34" charset="-120"/>
+              </a:rPr>
+              <a:t>incompleto</a:t>
+            </a:r>
+            <a:r>
+              <a:rPr lang="en-US" sz="1150" dirty="0" smtClean="0">
+                <a:solidFill>
+                  <a:srgbClr val="FFFFFF"/>
+                </a:solidFill>
+                <a:latin typeface="Calibri" pitchFamily="34" charset="0"/>
+                <a:ea typeface="Calibri" pitchFamily="34" charset="-122"/>
+                <a:cs typeface="Calibri" pitchFamily="34" charset="-120"/>
+              </a:rPr>
+              <a:t> </a:t>
+            </a:r>
+            <a:r>
+              <a:rPr lang="en-US" sz="1150" dirty="0" err="1" smtClean="0">
+                <a:solidFill>
+                  <a:srgbClr val="FFFFFF"/>
+                </a:solidFill>
+                <a:latin typeface="Calibri" pitchFamily="34" charset="0"/>
+                <a:ea typeface="Calibri" pitchFamily="34" charset="-122"/>
+                <a:cs typeface="Calibri" pitchFamily="34" charset="-120"/>
+              </a:rPr>
+              <a:t>não</a:t>
+            </a:r>
+            <a:r>
+              <a:rPr lang="en-US" sz="1150" dirty="0" smtClean="0">
+                <a:solidFill>
+                  <a:srgbClr val="FFFFFF"/>
+                </a:solidFill>
+                <a:latin typeface="Calibri" pitchFamily="34" charset="0"/>
+                <a:ea typeface="Calibri" pitchFamily="34" charset="-122"/>
+                <a:cs typeface="Calibri" pitchFamily="34" charset="-120"/>
+              </a:rPr>
+              <a:t> </a:t>
+            </a:r>
+            <a:r>
+              <a:rPr lang="en-US" sz="1150" dirty="0" err="1" smtClean="0">
+                <a:solidFill>
+                  <a:srgbClr val="FFFFFF"/>
+                </a:solidFill>
+                <a:latin typeface="Calibri" pitchFamily="34" charset="0"/>
+                <a:ea typeface="Calibri" pitchFamily="34" charset="-122"/>
+                <a:cs typeface="Calibri" pitchFamily="34" charset="-120"/>
+              </a:rPr>
+              <a:t>consegue</a:t>
+            </a:r>
+            <a:r>
+              <a:rPr lang="en-US" sz="1150" dirty="0" smtClean="0">
+                <a:solidFill>
+                  <a:srgbClr val="FFFFFF"/>
+                </a:solidFill>
+                <a:latin typeface="Calibri" pitchFamily="34" charset="0"/>
+                <a:ea typeface="Calibri" pitchFamily="34" charset="-122"/>
+                <a:cs typeface="Calibri" pitchFamily="34" charset="-120"/>
+              </a:rPr>
+              <a:t>.</a:t>
             </a:r>
             <a:endParaRPr lang="en-US" sz="1150" dirty="0"/>
           </a:p>
@@ -4016,6 +4267,28 @@
               <a:buNone/>
             </a:pPr>
             <a:r>
+              <a:rPr lang="en-US" sz="1150" dirty="0" err="1" smtClean="0">
+                <a:solidFill>
+                  <a:srgbClr val="FFFFFF"/>
+                </a:solidFill>
+                <a:latin typeface="Calibri" pitchFamily="34" charset="0"/>
+                <a:ea typeface="Calibri" pitchFamily="34" charset="-122"/>
+                <a:cs typeface="Calibri" pitchFamily="34" charset="-120"/>
+              </a:rPr>
+              <a:t>Falta</a:t>
+            </a:r>
+            <a:r>
+              <a:rPr lang="en-US" sz="1150" dirty="0" smtClean="0">
+                <a:solidFill>
+                  <a:srgbClr val="FFFFFF"/>
+                </a:solidFill>
+                <a:latin typeface="Calibri" pitchFamily="34" charset="0"/>
+                <a:ea typeface="Calibri" pitchFamily="34" charset="-122"/>
+                <a:cs typeface="Calibri" pitchFamily="34" charset="-120"/>
+              </a:rPr>
+              <a:t> o </a:t>
+            </a:r>
+            <a:r>
               <a:rPr lang="en-US" sz="1150" dirty="0">
                 <a:solidFill>
                   <a:srgbClr val="FFFFFF"/>
@@ -4024,10 +4297,10 @@
                 <a:ea typeface="Calibri" pitchFamily="34" charset="-122"/>
                 <a:cs typeface="Calibri" pitchFamily="34" charset="-120"/>
               </a:rPr>
-              <a:t>Faltam a tag de conversão no Google e o pixel na landing page. Nenhum dos dois impede captar lead nem vender: eles liberam a </a:t>
-            </a:r>
-            <a:r>
-              <a:rPr lang="en-US" sz="1150" dirty="0" err="1">
+              <a:t>pixel na landing page. </a:t>
+            </a:r>
+            <a:r>
+              <a:rPr lang="en-US" sz="1150" dirty="0" err="1" smtClean="0">
                 <a:solidFill>
                   <a:srgbClr val="FFFFFF"/>
                 </a:solidFill>
@@ -4035,10 +4308,10 @@
                 <a:ea typeface="Calibri" pitchFamily="34" charset="-122"/>
                 <a:cs typeface="Calibri" pitchFamily="34" charset="-120"/>
               </a:rPr>
-              <a:t>otimização</a:t>
-            </a:r>
-            <a:r>
-              <a:rPr lang="en-US" sz="1150" dirty="0">
+              <a:t>Isso</a:t>
+            </a:r>
+            <a:r>
+              <a:rPr lang="en-US" sz="1150" dirty="0" smtClean="0">
                 <a:solidFill>
                   <a:srgbClr val="FFFFFF"/>
                 </a:solidFill>
@@ -4057,10 +4330,10 @@
                 <a:ea typeface="Calibri" pitchFamily="34" charset="-122"/>
                 <a:cs typeface="Calibri" pitchFamily="34" charset="-120"/>
               </a:rPr>
-              <a:t>e </a:t>
-            </a:r>
-            <a:r>
-              <a:rPr lang="en-US" sz="1150" dirty="0">
+              <a:t>é </a:t>
+            </a:r>
+            <a:r>
+              <a:rPr lang="en-US" sz="1150" dirty="0" err="1" smtClean="0">
                 <a:solidFill>
                   <a:srgbClr val="FFFFFF"/>
                 </a:solidFill>
@@ -4068,7 +4341,238 @@
                 <a:ea typeface="Calibri" pitchFamily="34" charset="-122"/>
                 <a:cs typeface="Calibri" pitchFamily="34" charset="-120"/>
               </a:rPr>
-              <a:t>o retargeting, ganhos de eficiência já no plano dos próximos 14 dias.</a:t>
+              <a:t>necessário</a:t>
+            </a:r>
+            <a:r>
+              <a:rPr lang="en-US" sz="1150" dirty="0" smtClean="0">
+                <a:solidFill>
+                  <a:srgbClr val="FFFFFF"/>
+                </a:solidFill>
+                <a:latin typeface="Calibri" pitchFamily="34" charset="0"/>
+                <a:ea typeface="Calibri" pitchFamily="34" charset="-122"/>
+                <a:cs typeface="Calibri" pitchFamily="34" charset="-120"/>
+              </a:rPr>
+              <a:t> </a:t>
+            </a:r>
+            <a:r>
+              <a:rPr lang="en-US" sz="1150" dirty="0" err="1" smtClean="0">
+                <a:solidFill>
+                  <a:srgbClr val="FFFFFF"/>
+                </a:solidFill>
+                <a:latin typeface="Calibri" pitchFamily="34" charset="0"/>
+                <a:ea typeface="Calibri" pitchFamily="34" charset="-122"/>
+                <a:cs typeface="Calibri" pitchFamily="34" charset="-120"/>
+              </a:rPr>
+              <a:t>apenas</a:t>
+            </a:r>
+            <a:r>
+              <a:rPr lang="en-US" sz="1150" dirty="0" smtClean="0">
+                <a:solidFill>
+                  <a:srgbClr val="FFFFFF"/>
+                </a:solidFill>
+                <a:latin typeface="Calibri" pitchFamily="34" charset="0"/>
+                <a:ea typeface="Calibri" pitchFamily="34" charset="-122"/>
+                <a:cs typeface="Calibri" pitchFamily="34" charset="-120"/>
+              </a:rPr>
+              <a:t> para </a:t>
+            </a:r>
+            <a:r>
+              <a:rPr lang="en-US" sz="1150" dirty="0" err="1" smtClean="0">
+                <a:solidFill>
+                  <a:srgbClr val="FFFFFF"/>
+                </a:solidFill>
+                <a:latin typeface="Calibri" pitchFamily="34" charset="0"/>
+                <a:ea typeface="Calibri" pitchFamily="34" charset="-122"/>
+                <a:cs typeface="Calibri" pitchFamily="34" charset="-120"/>
+              </a:rPr>
+              <a:t>direcionado</a:t>
+            </a:r>
+            <a:r>
+              <a:rPr lang="en-US" sz="1150" dirty="0" smtClean="0">
+                <a:solidFill>
+                  <a:srgbClr val="FFFFFF"/>
+                </a:solidFill>
+                <a:latin typeface="Calibri" pitchFamily="34" charset="0"/>
+                <a:ea typeface="Calibri" pitchFamily="34" charset="-122"/>
+                <a:cs typeface="Calibri" pitchFamily="34" charset="-120"/>
+              </a:rPr>
+              <a:t> do Meta à LP, mas </a:t>
+            </a:r>
+            <a:r>
+              <a:rPr lang="en-US" sz="1150" dirty="0" err="1" smtClean="0">
+                <a:solidFill>
+                  <a:srgbClr val="FFFFFF"/>
+                </a:solidFill>
+                <a:latin typeface="Calibri" pitchFamily="34" charset="0"/>
+                <a:ea typeface="Calibri" pitchFamily="34" charset="-122"/>
+                <a:cs typeface="Calibri" pitchFamily="34" charset="-120"/>
+              </a:rPr>
+              <a:t>como</a:t>
+            </a:r>
+            <a:r>
+              <a:rPr lang="en-US" sz="1150" dirty="0" smtClean="0">
+                <a:solidFill>
+                  <a:srgbClr val="FFFFFF"/>
+                </a:solidFill>
+                <a:latin typeface="Calibri" pitchFamily="34" charset="0"/>
+                <a:ea typeface="Calibri" pitchFamily="34" charset="-122"/>
+                <a:cs typeface="Calibri" pitchFamily="34" charset="-120"/>
+              </a:rPr>
+              <a:t> </a:t>
+            </a:r>
+            <a:r>
+              <a:rPr lang="en-US" sz="1150" dirty="0" err="1" smtClean="0">
+                <a:solidFill>
+                  <a:srgbClr val="FFFFFF"/>
+                </a:solidFill>
+                <a:latin typeface="Calibri" pitchFamily="34" charset="0"/>
+                <a:ea typeface="Calibri" pitchFamily="34" charset="-122"/>
+                <a:cs typeface="Calibri" pitchFamily="34" charset="-120"/>
+              </a:rPr>
+              <a:t>formulários</a:t>
+            </a:r>
+            <a:r>
+              <a:rPr lang="en-US" sz="1150" dirty="0" smtClean="0">
+                <a:solidFill>
+                  <a:srgbClr val="FFFFFF"/>
+                </a:solidFill>
+                <a:latin typeface="Calibri" pitchFamily="34" charset="0"/>
+                <a:ea typeface="Calibri" pitchFamily="34" charset="-122"/>
+                <a:cs typeface="Calibri" pitchFamily="34" charset="-120"/>
+              </a:rPr>
+              <a:t> </a:t>
+            </a:r>
+            <a:r>
+              <a:rPr lang="en-US" sz="1150" dirty="0" err="1" smtClean="0">
+                <a:solidFill>
+                  <a:srgbClr val="FFFFFF"/>
+                </a:solidFill>
+                <a:latin typeface="Calibri" pitchFamily="34" charset="0"/>
+                <a:ea typeface="Calibri" pitchFamily="34" charset="-122"/>
+                <a:cs typeface="Calibri" pitchFamily="34" charset="-120"/>
+              </a:rPr>
+              <a:t>nativos</a:t>
+            </a:r>
+            <a:r>
+              <a:rPr lang="en-US" sz="1150" dirty="0" smtClean="0">
+                <a:solidFill>
+                  <a:srgbClr val="FFFFFF"/>
+                </a:solidFill>
+                <a:latin typeface="Calibri" pitchFamily="34" charset="0"/>
+                <a:ea typeface="Calibri" pitchFamily="34" charset="-122"/>
+                <a:cs typeface="Calibri" pitchFamily="34" charset="-120"/>
+              </a:rPr>
+              <a:t> tem </a:t>
+            </a:r>
+            <a:r>
+              <a:rPr lang="en-US" sz="1150" dirty="0" err="1" smtClean="0">
+                <a:solidFill>
+                  <a:srgbClr val="FFFFFF"/>
+                </a:solidFill>
+                <a:latin typeface="Calibri" pitchFamily="34" charset="0"/>
+                <a:ea typeface="Calibri" pitchFamily="34" charset="-122"/>
+                <a:cs typeface="Calibri" pitchFamily="34" charset="-120"/>
+              </a:rPr>
+              <a:t>bons</a:t>
+            </a:r>
+            <a:r>
+              <a:rPr lang="en-US" sz="1150" dirty="0" smtClean="0">
+                <a:solidFill>
+                  <a:srgbClr val="FFFFFF"/>
+                </a:solidFill>
+                <a:latin typeface="Calibri" pitchFamily="34" charset="0"/>
+                <a:ea typeface="Calibri" pitchFamily="34" charset="-122"/>
+                <a:cs typeface="Calibri" pitchFamily="34" charset="-120"/>
+              </a:rPr>
+              <a:t> </a:t>
+            </a:r>
+            <a:r>
+              <a:rPr lang="en-US" sz="1150" dirty="0" err="1" smtClean="0">
+                <a:solidFill>
+                  <a:srgbClr val="FFFFFF"/>
+                </a:solidFill>
+                <a:latin typeface="Calibri" pitchFamily="34" charset="0"/>
+                <a:ea typeface="Calibri" pitchFamily="34" charset="-122"/>
+                <a:cs typeface="Calibri" pitchFamily="34" charset="-120"/>
+              </a:rPr>
+              <a:t>resultados</a:t>
+            </a:r>
+            <a:r>
+              <a:rPr lang="en-US" sz="1150" dirty="0" smtClean="0">
+                <a:solidFill>
+                  <a:srgbClr val="FFFFFF"/>
+                </a:solidFill>
+                <a:latin typeface="Calibri" pitchFamily="34" charset="0"/>
+                <a:ea typeface="Calibri" pitchFamily="34" charset="-122"/>
+                <a:cs typeface="Calibri" pitchFamily="34" charset="-120"/>
+              </a:rPr>
+              <a:t>, </a:t>
+            </a:r>
+            <a:r>
+              <a:rPr lang="en-US" sz="1150" dirty="0" err="1" smtClean="0">
+                <a:solidFill>
+                  <a:srgbClr val="FFFFFF"/>
+                </a:solidFill>
+                <a:latin typeface="Calibri" pitchFamily="34" charset="0"/>
+                <a:ea typeface="Calibri" pitchFamily="34" charset="-122"/>
+                <a:cs typeface="Calibri" pitchFamily="34" charset="-120"/>
+              </a:rPr>
+              <a:t>não</a:t>
+            </a:r>
+            <a:r>
+              <a:rPr lang="en-US" sz="1150" dirty="0" smtClean="0">
+                <a:solidFill>
+                  <a:srgbClr val="FFFFFF"/>
+                </a:solidFill>
+                <a:latin typeface="Calibri" pitchFamily="34" charset="0"/>
+                <a:ea typeface="Calibri" pitchFamily="34" charset="-122"/>
+                <a:cs typeface="Calibri" pitchFamily="34" charset="-120"/>
+              </a:rPr>
+              <a:t> se </a:t>
+            </a:r>
+            <a:r>
+              <a:rPr lang="en-US" sz="1150" dirty="0" err="1" smtClean="0">
+                <a:solidFill>
+                  <a:srgbClr val="FFFFFF"/>
+                </a:solidFill>
+                <a:latin typeface="Calibri" pitchFamily="34" charset="0"/>
+                <a:ea typeface="Calibri" pitchFamily="34" charset="-122"/>
+                <a:cs typeface="Calibri" pitchFamily="34" charset="-120"/>
+              </a:rPr>
+              <a:t>faz</a:t>
+            </a:r>
+            <a:r>
+              <a:rPr lang="en-US" sz="1150" dirty="0" smtClean="0">
+                <a:solidFill>
+                  <a:srgbClr val="FFFFFF"/>
+                </a:solidFill>
+                <a:latin typeface="Calibri" pitchFamily="34" charset="0"/>
+                <a:ea typeface="Calibri" pitchFamily="34" charset="-122"/>
+                <a:cs typeface="Calibri" pitchFamily="34" charset="-120"/>
+              </a:rPr>
+              <a:t> </a:t>
+            </a:r>
+            <a:r>
+              <a:rPr lang="en-US" sz="1150" dirty="0" err="1" smtClean="0">
+                <a:solidFill>
+                  <a:srgbClr val="FFFFFF"/>
+                </a:solidFill>
+                <a:latin typeface="Calibri" pitchFamily="34" charset="0"/>
+                <a:ea typeface="Calibri" pitchFamily="34" charset="-122"/>
+                <a:cs typeface="Calibri" pitchFamily="34" charset="-120"/>
+              </a:rPr>
+              <a:t>necessário</a:t>
+            </a:r>
+            <a:r>
+              <a:rPr lang="en-US" sz="1150" dirty="0" smtClean="0">
+                <a:solidFill>
+                  <a:srgbClr val="FFFFFF"/>
+                </a:solidFill>
+                <a:latin typeface="Calibri" pitchFamily="34" charset="0"/>
+                <a:ea typeface="Calibri" pitchFamily="34" charset="-122"/>
+                <a:cs typeface="Calibri" pitchFamily="34" charset="-120"/>
+              </a:rPr>
+              <a:t> agora.</a:t>
             </a:r>
             <a:endParaRPr lang="en-US" sz="1150" dirty="0"/>
           </a:p>
@@ -4697,7 +5201,7 @@
                           <a:ea typeface="Calibri" pitchFamily="34" charset="-122"/>
                           <a:cs typeface="Calibri" pitchFamily="34" charset="-120"/>
                         </a:rPr>
-                        <a:t>R$ 1.365,80</a:t>
+                        <a:t>R$ 1.844,73</a:t>
                       </a:r>
                       <a:endParaRPr lang="en-US" sz="1050" dirty="0">
                         <a:latin typeface="Calibri" charset="0"/>
@@ -4765,7 +5269,7 @@
                           <a:ea typeface="Calibri" pitchFamily="34" charset="-122"/>
                           <a:cs typeface="Calibri" pitchFamily="34" charset="-120"/>
                         </a:rPr>
-                        <a:t>24</a:t>
+                        <a:t>33</a:t>
                       </a:r>
                       <a:endParaRPr lang="en-US" sz="1050" dirty="0">
                         <a:latin typeface="Calibri" charset="0"/>
@@ -4833,7 +5337,7 @@
                           <a:ea typeface="Calibri" pitchFamily="34" charset="-122"/>
                           <a:cs typeface="Calibri" pitchFamily="34" charset="-120"/>
                         </a:rPr>
-                        <a:t>R$ 56,91</a:t>
+                        <a:t>R$ 55,90</a:t>
                       </a:r>
                       <a:endParaRPr lang="en-US" sz="1050" dirty="0">
                         <a:latin typeface="Calibri" charset="0"/>
@@ -5039,7 +5543,7 @@
                           <a:ea typeface="Calibri" pitchFamily="34" charset="-122"/>
                           <a:cs typeface="Calibri" pitchFamily="34" charset="-120"/>
                         </a:rPr>
-                        <a:t>R$ 1.148,06</a:t>
+                        <a:t>R$ 1.307,25</a:t>
                       </a:r>
                       <a:endParaRPr lang="en-US" sz="1050" dirty="0">
                         <a:latin typeface="Calibri" charset="0"/>
@@ -5175,7 +5679,7 @@
                           <a:ea typeface="Calibri" pitchFamily="34" charset="-122"/>
                           <a:cs typeface="Calibri" pitchFamily="34" charset="-120"/>
                         </a:rPr>
-                        <a:t>R$ 191,34</a:t>
+                        <a:t>R$ 217,88</a:t>
                       </a:r>
                       <a:endParaRPr lang="en-US" sz="1050" dirty="0">
                         <a:latin typeface="Calibri" charset="0"/>
@@ -5381,7 +5885,7 @@
                           <a:ea typeface="Calibri" pitchFamily="34" charset="-122"/>
                           <a:cs typeface="Calibri" pitchFamily="34" charset="-120"/>
                         </a:rPr>
-                        <a:t>R$ 1.100,62</a:t>
+                        <a:t>R$ 1.689,96</a:t>
                       </a:r>
                       <a:endParaRPr lang="en-US" sz="1050" dirty="0">
                         <a:latin typeface="Calibri" charset="0"/>
@@ -5449,7 +5953,7 @@
                           <a:ea typeface="Calibri" pitchFamily="34" charset="-122"/>
                           <a:cs typeface="Calibri" pitchFamily="34" charset="-120"/>
                         </a:rPr>
-                        <a:t>3</a:t>
+                        <a:t>5</a:t>
                       </a:r>
                       <a:endParaRPr lang="en-US" sz="1050" dirty="0">
                         <a:latin typeface="Calibri" charset="0"/>
@@ -5517,7 +6021,7 @@
                           <a:ea typeface="Calibri" pitchFamily="34" charset="-122"/>
                           <a:cs typeface="Calibri" pitchFamily="34" charset="-120"/>
                         </a:rPr>
-                        <a:t>amostra pequena</a:t>
+                        <a:t>R$ 337,99</a:t>
                       </a:r>
                       <a:endParaRPr lang="en-US" sz="1050" dirty="0">
                         <a:latin typeface="Calibri" charset="0"/>
@@ -5585,7 +6089,7 @@
                           <a:ea typeface="Calibri" pitchFamily="34" charset="-122"/>
                           <a:cs typeface="Calibri" pitchFamily="34" charset="-120"/>
                         </a:rPr>
-                        <a:t>Busca ativa, clique a R$ 8,09</a:t>
+                        <a:t>Busca ativa, clique a R$ 6,90</a:t>
                       </a:r>
                       <a:endParaRPr lang="en-US" sz="1050" dirty="0">
                         <a:latin typeface="Calibri" charset="0"/>
@@ -5723,7 +6227,7 @@
                           <a:ea typeface="Calibri" pitchFamily="34" charset="-122"/>
                           <a:cs typeface="Calibri" pitchFamily="34" charset="-120"/>
                         </a:rPr>
-                        <a:t>R$ 498,20</a:t>
+                        <a:t>R$ 592,36</a:t>
                       </a:r>
                       <a:endParaRPr lang="en-US" sz="1050" dirty="0">
                         <a:latin typeface="Calibri" charset="0"/>
@@ -5927,7 +6431,7 @@
                           <a:ea typeface="Calibri" pitchFamily="34" charset="-122"/>
                           <a:cs typeface="Calibri" pitchFamily="34" charset="-120"/>
                         </a:rPr>
-                        <a:t>Volume insuficiente para concluir</a:t>
+                        <a:t>Zero lead. Volume insuficiente e caro</a:t>
                       </a:r>
                       <a:endParaRPr lang="en-US" sz="1050" dirty="0">
                         <a:latin typeface="Calibri" charset="0"/>
@@ -6065,7 +6569,7 @@
                           <a:ea typeface="Calibri" pitchFamily="34" charset="-122"/>
                           <a:cs typeface="Calibri" pitchFamily="34" charset="-120"/>
                         </a:rPr>
-                        <a:t>R$ 4.112,68</a:t>
+                        <a:t>R$ 5.434,30</a:t>
                       </a:r>
                       <a:endParaRPr lang="en-US" sz="1050" dirty="0">
                         <a:latin typeface="Calibri" charset="0"/>
@@ -6133,7 +6637,7 @@
                           <a:ea typeface="Calibri" pitchFamily="34" charset="-122"/>
                           <a:cs typeface="Calibri" pitchFamily="34" charset="-120"/>
                         </a:rPr>
-                        <a:t>33</a:t>
+                        <a:t>44</a:t>
                       </a:r>
                       <a:endParaRPr lang="en-US" sz="1050" dirty="0">
                         <a:latin typeface="Calibri" charset="0"/>
@@ -6269,7 +6773,7 @@
                           <a:ea typeface="Calibri" pitchFamily="34" charset="-122"/>
                           <a:cs typeface="Calibri" pitchFamily="34" charset="-120"/>
                         </a:rPr>
-                        <a:t>Mais 7 contatos por outros canais</a:t>
+                        <a:t>Mais 10 contatos por outros canais</a:t>
                       </a:r>
                       <a:endParaRPr lang="en-US" sz="1050" dirty="0">
                         <a:latin typeface="Calibri" charset="0"/>
@@ -6351,6 +6855,13 @@
             <a:prstDash val="solid"/>
           </a:ln>
         </p:spPr>
+        <p:txBody>
+          <a:bodyPr/>
+          <a:lstStyle/>
+          <a:p>
+            <a:endParaRPr/>
+          </a:p>
+        </p:txBody>
       </p:sp>
       <p:sp>
         <p:nvSpPr>
@@ -6790,6 +7301,13 @@
             <a:prstDash val="solid"/>
           </a:ln>
         </p:spPr>
+        <p:txBody>
+          <a:bodyPr/>
+          <a:lstStyle/>
+          <a:p>
+            <a:endParaRPr/>
+          </a:p>
+        </p:txBody>
       </p:sp>
       <p:sp>
         <p:nvSpPr>
@@ -6827,7 +7345,7 @@
                 <a:ea typeface="Calibri" pitchFamily="34" charset="-122"/>
                 <a:cs typeface="Calibri" pitchFamily="34" charset="-120"/>
               </a:rPr>
-              <a:t>Os EUA responderam melhor nos dois canais: no Google, o clique alemão sai a R$ 27,68 contra R$ 8,09.</a:t>
+              <a:t>Os EUA responderam melhor nos dois canais: no Google, o clique alemão sai a R$ 24,68 contra R$ 6,90.</a:t>
             </a:r>
             <a:endParaRPr lang="en-US" sz="1200" dirty="0"/>
           </a:p>
@@ -6857,6 +7375,13 @@
             <a:prstDash val="solid"/>
           </a:ln>
         </p:spPr>
+        <p:txBody>
+          <a:bodyPr/>
+          <a:lstStyle/>
+          <a:p>
+            <a:endParaRPr/>
+          </a:p>
+        </p:txBody>
       </p:sp>
       <p:sp>
         <p:nvSpPr>
@@ -6924,6 +7449,13 @@
             <a:prstDash val="solid"/>
           </a:ln>
         </p:spPr>
+        <p:txBody>
+          <a:bodyPr/>
+          <a:lstStyle/>
+          <a:p>
+            <a:endParaRPr/>
+          </a:p>
+        </p:txBody>
       </p:sp>
       <p:sp>
         <p:nvSpPr>
@@ -6961,7 +7493,7 @@
                 <a:ea typeface="Calibri" pitchFamily="34" charset="-122"/>
                 <a:cs typeface="Calibri" pitchFamily="34" charset="-120"/>
               </a:rPr>
-              <a:t>O custo por lead do Google ainda não é legível: 3 leads são amostra pequena para número de gestão.</a:t>
+              <a:t>O custo por lead do Google ainda não é legível: 5 leads são amostra pequena para número de gestão.</a:t>
             </a:r>
             <a:endParaRPr lang="en-US" sz="1200" dirty="0"/>
           </a:p>
@@ -6997,10 +7529,10 @@
                 <a:ea typeface="Calibri" pitchFamily="34" charset="-122"/>
                 <a:cs typeface="Calibri" pitchFamily="34" charset="-120"/>
               </a:rPr>
-              <a:t>Fonte: Google Ads (01 a 14/07) e Meta Ads (03 a 14/07). Leads contados na planilha de </a:t>
-            </a:r>
-            <a:r>
-              <a:rPr lang="en-US" sz="900" i="1" dirty="0" err="1" smtClean="0">
+              <a:t>Fonte: Google Ads (01 a 22/07) e Meta Ads (03 a 21/07). Leads contados na planilha de controle. Nos primeiros 14 dias a verba diária rodou de propósito acima do teto mensal; a partir de 15/07 foi reduzida à metade. Leitura orienta a escolha, não é orçamento fechado.</a:t>
+            </a:r>
+            <a:r>
+              <a:rPr lang="en-US" sz="900" i="1" dirty="0" smtClean="0">
                 <a:solidFill>
                   <a:srgbClr val="6E7B70"/>
                 </a:solidFill>
@@ -7008,18 +7540,7 @@
                 <a:ea typeface="Calibri" pitchFamily="34" charset="-122"/>
                 <a:cs typeface="Calibri" pitchFamily="34" charset="-120"/>
               </a:rPr>
-              <a:t>controle</a:t>
-            </a:r>
-            <a:r>
-              <a:rPr lang="en-US" sz="900" i="1" dirty="0" smtClean="0">
-                <a:solidFill>
-                  <a:srgbClr val="6E7B70"/>
-                </a:solidFill>
-                <a:latin typeface="Calibri" pitchFamily="34" charset="0"/>
-                <a:ea typeface="Calibri" pitchFamily="34" charset="-122"/>
-                <a:cs typeface="Calibri" pitchFamily="34" charset="-120"/>
-              </a:rPr>
-              <a:t>.</a:t>
+              <a:t/>
             </a:r>
             <a:br>
               <a:rPr lang="en-US" sz="900" i="1" dirty="0" smtClean="0">
@@ -7031,468 +7552,6 @@
                 <a:cs typeface="Calibri" pitchFamily="34" charset="-120"/>
               </a:rPr>
             </a:br>
-            <a:r>
-              <a:rPr lang="en-US" sz="900" i="1" dirty="0" smtClean="0">
-                <a:solidFill>
-                  <a:srgbClr val="6E7B70"/>
-                </a:solidFill>
-                <a:latin typeface="Calibri" pitchFamily="34" charset="0"/>
-                <a:ea typeface="Calibri" pitchFamily="34" charset="-122"/>
-                <a:cs typeface="Calibri" pitchFamily="34" charset="-120"/>
-              </a:rPr>
-              <a:t>Nos </a:t>
-            </a:r>
-            <a:r>
-              <a:rPr lang="en-US" sz="900" i="1" dirty="0" err="1">
-                <a:solidFill>
-                  <a:srgbClr val="6E7B70"/>
-                </a:solidFill>
-                <a:latin typeface="Calibri" pitchFamily="34" charset="0"/>
-                <a:ea typeface="Calibri" pitchFamily="34" charset="-122"/>
-                <a:cs typeface="Calibri" pitchFamily="34" charset="-120"/>
-              </a:rPr>
-              <a:t>primeiros</a:t>
-            </a:r>
-            <a:r>
-              <a:rPr lang="en-US" sz="900" i="1" dirty="0">
-                <a:solidFill>
-                  <a:srgbClr val="6E7B70"/>
-                </a:solidFill>
-                <a:latin typeface="Calibri" pitchFamily="34" charset="0"/>
-                <a:ea typeface="Calibri" pitchFamily="34" charset="-122"/>
-                <a:cs typeface="Calibri" pitchFamily="34" charset="-120"/>
-              </a:rPr>
-              <a:t> 14 </a:t>
-            </a:r>
-            <a:r>
-              <a:rPr lang="en-US" sz="900" i="1" dirty="0" err="1">
-                <a:solidFill>
-                  <a:srgbClr val="6E7B70"/>
-                </a:solidFill>
-                <a:latin typeface="Calibri" pitchFamily="34" charset="0"/>
-                <a:ea typeface="Calibri" pitchFamily="34" charset="-122"/>
-                <a:cs typeface="Calibri" pitchFamily="34" charset="-120"/>
-              </a:rPr>
-              <a:t>dias</a:t>
-            </a:r>
-            <a:r>
-              <a:rPr lang="en-US" sz="900" i="1" dirty="0">
-                <a:solidFill>
-                  <a:srgbClr val="6E7B70"/>
-                </a:solidFill>
-                <a:latin typeface="Calibri" pitchFamily="34" charset="0"/>
-                <a:ea typeface="Calibri" pitchFamily="34" charset="-122"/>
-                <a:cs typeface="Calibri" pitchFamily="34" charset="-120"/>
-              </a:rPr>
-              <a:t>, a </a:t>
-            </a:r>
-            <a:r>
-              <a:rPr lang="en-US" sz="900" i="1" dirty="0" err="1">
-                <a:solidFill>
-                  <a:srgbClr val="6E7B70"/>
-                </a:solidFill>
-                <a:latin typeface="Calibri" pitchFamily="34" charset="0"/>
-                <a:ea typeface="Calibri" pitchFamily="34" charset="-122"/>
-                <a:cs typeface="Calibri" pitchFamily="34" charset="-120"/>
-              </a:rPr>
-              <a:t>verba</a:t>
-            </a:r>
-            <a:r>
-              <a:rPr lang="en-US" sz="900" i="1" dirty="0">
-                <a:solidFill>
-                  <a:srgbClr val="6E7B70"/>
-                </a:solidFill>
-                <a:latin typeface="Calibri" pitchFamily="34" charset="0"/>
-                <a:ea typeface="Calibri" pitchFamily="34" charset="-122"/>
-                <a:cs typeface="Calibri" pitchFamily="34" charset="-120"/>
-              </a:rPr>
-              <a:t> </a:t>
-            </a:r>
-            <a:r>
-              <a:rPr lang="en-US" sz="900" i="1" dirty="0" err="1">
-                <a:solidFill>
-                  <a:srgbClr val="6E7B70"/>
-                </a:solidFill>
-                <a:latin typeface="Calibri" pitchFamily="34" charset="0"/>
-                <a:ea typeface="Calibri" pitchFamily="34" charset="-122"/>
-                <a:cs typeface="Calibri" pitchFamily="34" charset="-120"/>
-              </a:rPr>
-              <a:t>diária</a:t>
-            </a:r>
-            <a:r>
-              <a:rPr lang="en-US" sz="900" i="1" dirty="0">
-                <a:solidFill>
-                  <a:srgbClr val="6E7B70"/>
-                </a:solidFill>
-                <a:latin typeface="Calibri" pitchFamily="34" charset="0"/>
-                <a:ea typeface="Calibri" pitchFamily="34" charset="-122"/>
-                <a:cs typeface="Calibri" pitchFamily="34" charset="-120"/>
-              </a:rPr>
-              <a:t> </a:t>
-            </a:r>
-            <a:r>
-              <a:rPr lang="en-US" sz="900" i="1" dirty="0" err="1">
-                <a:solidFill>
-                  <a:srgbClr val="6E7B70"/>
-                </a:solidFill>
-                <a:latin typeface="Calibri" pitchFamily="34" charset="0"/>
-                <a:ea typeface="Calibri" pitchFamily="34" charset="-122"/>
-                <a:cs typeface="Calibri" pitchFamily="34" charset="-120"/>
-              </a:rPr>
-              <a:t>rodou</a:t>
-            </a:r>
-            <a:r>
-              <a:rPr lang="en-US" sz="900" i="1" dirty="0">
-                <a:solidFill>
-                  <a:srgbClr val="6E7B70"/>
-                </a:solidFill>
-                <a:latin typeface="Calibri" pitchFamily="34" charset="0"/>
-                <a:ea typeface="Calibri" pitchFamily="34" charset="-122"/>
-                <a:cs typeface="Calibri" pitchFamily="34" charset="-120"/>
-              </a:rPr>
-              <a:t> de </a:t>
-            </a:r>
-            <a:r>
-              <a:rPr lang="en-US" sz="900" i="1" dirty="0" err="1">
-                <a:solidFill>
-                  <a:srgbClr val="6E7B70"/>
-                </a:solidFill>
-                <a:latin typeface="Calibri" pitchFamily="34" charset="0"/>
-                <a:ea typeface="Calibri" pitchFamily="34" charset="-122"/>
-                <a:cs typeface="Calibri" pitchFamily="34" charset="-120"/>
-              </a:rPr>
-              <a:t>propósito</a:t>
-            </a:r>
-            <a:r>
-              <a:rPr lang="en-US" sz="900" i="1" dirty="0">
-                <a:solidFill>
-                  <a:srgbClr val="6E7B70"/>
-                </a:solidFill>
-                <a:latin typeface="Calibri" pitchFamily="34" charset="0"/>
-                <a:ea typeface="Calibri" pitchFamily="34" charset="-122"/>
-                <a:cs typeface="Calibri" pitchFamily="34" charset="-120"/>
-              </a:rPr>
-              <a:t> </a:t>
-            </a:r>
-            <a:r>
-              <a:rPr lang="en-US" sz="900" i="1" dirty="0" err="1">
-                <a:solidFill>
-                  <a:srgbClr val="6E7B70"/>
-                </a:solidFill>
-                <a:latin typeface="Calibri" pitchFamily="34" charset="0"/>
-                <a:ea typeface="Calibri" pitchFamily="34" charset="-122"/>
-                <a:cs typeface="Calibri" pitchFamily="34" charset="-120"/>
-              </a:rPr>
-              <a:t>acima</a:t>
-            </a:r>
-            <a:r>
-              <a:rPr lang="en-US" sz="900" i="1" dirty="0">
-                <a:solidFill>
-                  <a:srgbClr val="6E7B70"/>
-                </a:solidFill>
-                <a:latin typeface="Calibri" pitchFamily="34" charset="0"/>
-                <a:ea typeface="Calibri" pitchFamily="34" charset="-122"/>
-                <a:cs typeface="Calibri" pitchFamily="34" charset="-120"/>
-              </a:rPr>
-              <a:t> do </a:t>
-            </a:r>
-            <a:r>
-              <a:rPr lang="en-US" sz="900" i="1" dirty="0" err="1">
-                <a:solidFill>
-                  <a:srgbClr val="6E7B70"/>
-                </a:solidFill>
-                <a:latin typeface="Calibri" pitchFamily="34" charset="0"/>
-                <a:ea typeface="Calibri" pitchFamily="34" charset="-122"/>
-                <a:cs typeface="Calibri" pitchFamily="34" charset="-120"/>
-              </a:rPr>
-              <a:t>teto</a:t>
-            </a:r>
-            <a:r>
-              <a:rPr lang="en-US" sz="900" i="1" dirty="0">
-                <a:solidFill>
-                  <a:srgbClr val="6E7B70"/>
-                </a:solidFill>
-                <a:latin typeface="Calibri" pitchFamily="34" charset="0"/>
-                <a:ea typeface="Calibri" pitchFamily="34" charset="-122"/>
-                <a:cs typeface="Calibri" pitchFamily="34" charset="-120"/>
-              </a:rPr>
-              <a:t> </a:t>
-            </a:r>
-            <a:r>
-              <a:rPr lang="en-US" sz="900" i="1" dirty="0" smtClean="0">
-                <a:solidFill>
-                  <a:srgbClr val="6E7B70"/>
-                </a:solidFill>
-                <a:latin typeface="Calibri" pitchFamily="34" charset="0"/>
-                <a:ea typeface="Calibri" pitchFamily="34" charset="-122"/>
-                <a:cs typeface="Calibri" pitchFamily="34" charset="-120"/>
-              </a:rPr>
-              <a:t>mensal. </a:t>
-            </a:r>
-            <a:r>
-              <a:rPr lang="en-US" sz="900" i="1" dirty="0" err="1">
-                <a:solidFill>
-                  <a:srgbClr val="6E7B70"/>
-                </a:solidFill>
-                <a:latin typeface="Calibri" pitchFamily="34" charset="0"/>
-                <a:ea typeface="Calibri" pitchFamily="34" charset="-122"/>
-                <a:cs typeface="Calibri" pitchFamily="34" charset="-120"/>
-              </a:rPr>
-              <a:t>Esse</a:t>
-            </a:r>
-            <a:r>
-              <a:rPr lang="en-US" sz="900" i="1" dirty="0">
-                <a:solidFill>
-                  <a:srgbClr val="6E7B70"/>
-                </a:solidFill>
-                <a:latin typeface="Calibri" pitchFamily="34" charset="0"/>
-                <a:ea typeface="Calibri" pitchFamily="34" charset="-122"/>
-                <a:cs typeface="Calibri" pitchFamily="34" charset="-120"/>
-              </a:rPr>
-              <a:t> </a:t>
-            </a:r>
-            <a:r>
-              <a:rPr lang="en-US" sz="900" i="1" dirty="0" err="1">
-                <a:solidFill>
-                  <a:srgbClr val="6E7B70"/>
-                </a:solidFill>
-                <a:latin typeface="Calibri" pitchFamily="34" charset="0"/>
-                <a:ea typeface="Calibri" pitchFamily="34" charset="-122"/>
-                <a:cs typeface="Calibri" pitchFamily="34" charset="-120"/>
-              </a:rPr>
-              <a:t>período</a:t>
-            </a:r>
-            <a:r>
-              <a:rPr lang="en-US" sz="900" i="1" dirty="0">
-                <a:solidFill>
-                  <a:srgbClr val="6E7B70"/>
-                </a:solidFill>
-                <a:latin typeface="Calibri" pitchFamily="34" charset="0"/>
-                <a:ea typeface="Calibri" pitchFamily="34" charset="-122"/>
-                <a:cs typeface="Calibri" pitchFamily="34" charset="-120"/>
-              </a:rPr>
-              <a:t> </a:t>
-            </a:r>
-            <a:r>
-              <a:rPr lang="en-US" sz="900" i="1" dirty="0" err="1">
-                <a:solidFill>
-                  <a:srgbClr val="6E7B70"/>
-                </a:solidFill>
-                <a:latin typeface="Calibri" pitchFamily="34" charset="0"/>
-                <a:ea typeface="Calibri" pitchFamily="34" charset="-122"/>
-                <a:cs typeface="Calibri" pitchFamily="34" charset="-120"/>
-              </a:rPr>
-              <a:t>já</a:t>
-            </a:r>
-            <a:r>
-              <a:rPr lang="en-US" sz="900" i="1" dirty="0">
-                <a:solidFill>
-                  <a:srgbClr val="6E7B70"/>
-                </a:solidFill>
-                <a:latin typeface="Calibri" pitchFamily="34" charset="0"/>
-                <a:ea typeface="Calibri" pitchFamily="34" charset="-122"/>
-                <a:cs typeface="Calibri" pitchFamily="34" charset="-120"/>
-              </a:rPr>
-              <a:t> </a:t>
-            </a:r>
-            <a:r>
-              <a:rPr lang="en-US" sz="900" i="1" dirty="0" err="1">
-                <a:solidFill>
-                  <a:srgbClr val="6E7B70"/>
-                </a:solidFill>
-                <a:latin typeface="Calibri" pitchFamily="34" charset="0"/>
-                <a:ea typeface="Calibri" pitchFamily="34" charset="-122"/>
-                <a:cs typeface="Calibri" pitchFamily="34" charset="-120"/>
-              </a:rPr>
-              <a:t>terminou</a:t>
-            </a:r>
-            <a:r>
-              <a:rPr lang="en-US" sz="900" i="1" dirty="0">
-                <a:solidFill>
-                  <a:srgbClr val="6E7B70"/>
-                </a:solidFill>
-                <a:latin typeface="Calibri" pitchFamily="34" charset="0"/>
-                <a:ea typeface="Calibri" pitchFamily="34" charset="-122"/>
-                <a:cs typeface="Calibri" pitchFamily="34" charset="-120"/>
-              </a:rPr>
-              <a:t>. </a:t>
-            </a:r>
-            <a:r>
-              <a:rPr lang="en-US" sz="900" i="1" dirty="0" err="1">
-                <a:solidFill>
-                  <a:srgbClr val="6E7B70"/>
-                </a:solidFill>
-                <a:latin typeface="Calibri" pitchFamily="34" charset="0"/>
-                <a:ea typeface="Calibri" pitchFamily="34" charset="-122"/>
-                <a:cs typeface="Calibri" pitchFamily="34" charset="-120"/>
-              </a:rPr>
-              <a:t>Leitura</a:t>
-            </a:r>
-            <a:r>
-              <a:rPr lang="en-US" sz="900" i="1" dirty="0">
-                <a:solidFill>
-                  <a:srgbClr val="6E7B70"/>
-                </a:solidFill>
-                <a:latin typeface="Calibri" pitchFamily="34" charset="0"/>
-                <a:ea typeface="Calibri" pitchFamily="34" charset="-122"/>
-                <a:cs typeface="Calibri" pitchFamily="34" charset="-120"/>
-              </a:rPr>
-              <a:t> </a:t>
-            </a:r>
-            <a:r>
-              <a:rPr lang="en-US" sz="900" i="1" dirty="0" err="1">
-                <a:solidFill>
-                  <a:srgbClr val="6E7B70"/>
-                </a:solidFill>
-                <a:latin typeface="Calibri" pitchFamily="34" charset="0"/>
-                <a:ea typeface="Calibri" pitchFamily="34" charset="-122"/>
-                <a:cs typeface="Calibri" pitchFamily="34" charset="-120"/>
-              </a:rPr>
-              <a:t>baseada</a:t>
-            </a:r>
-            <a:r>
-              <a:rPr lang="en-US" sz="900" i="1" dirty="0">
-                <a:solidFill>
-                  <a:srgbClr val="6E7B70"/>
-                </a:solidFill>
-                <a:latin typeface="Calibri" pitchFamily="34" charset="0"/>
-                <a:ea typeface="Calibri" pitchFamily="34" charset="-122"/>
-                <a:cs typeface="Calibri" pitchFamily="34" charset="-120"/>
-              </a:rPr>
-              <a:t> nesses 14 </a:t>
-            </a:r>
-            <a:r>
-              <a:rPr lang="en-US" sz="900" i="1" dirty="0" err="1">
-                <a:solidFill>
-                  <a:srgbClr val="6E7B70"/>
-                </a:solidFill>
-                <a:latin typeface="Calibri" pitchFamily="34" charset="0"/>
-                <a:ea typeface="Calibri" pitchFamily="34" charset="-122"/>
-                <a:cs typeface="Calibri" pitchFamily="34" charset="-120"/>
-              </a:rPr>
-              <a:t>dias</a:t>
-            </a:r>
-            <a:r>
-              <a:rPr lang="en-US" sz="900" i="1" dirty="0">
-                <a:solidFill>
-                  <a:srgbClr val="6E7B70"/>
-                </a:solidFill>
-                <a:latin typeface="Calibri" pitchFamily="34" charset="0"/>
-                <a:ea typeface="Calibri" pitchFamily="34" charset="-122"/>
-                <a:cs typeface="Calibri" pitchFamily="34" charset="-120"/>
-              </a:rPr>
-              <a:t>: </a:t>
-            </a:r>
-            <a:r>
-              <a:rPr lang="en-US" sz="900" i="1" dirty="0" err="1">
-                <a:solidFill>
-                  <a:srgbClr val="6E7B70"/>
-                </a:solidFill>
-                <a:latin typeface="Calibri" pitchFamily="34" charset="0"/>
-                <a:ea typeface="Calibri" pitchFamily="34" charset="-122"/>
-                <a:cs typeface="Calibri" pitchFamily="34" charset="-120"/>
-              </a:rPr>
-              <a:t>orienta</a:t>
-            </a:r>
-            <a:r>
-              <a:rPr lang="en-US" sz="900" i="1" dirty="0">
-                <a:solidFill>
-                  <a:srgbClr val="6E7B70"/>
-                </a:solidFill>
-                <a:latin typeface="Calibri" pitchFamily="34" charset="0"/>
-                <a:ea typeface="Calibri" pitchFamily="34" charset="-122"/>
-                <a:cs typeface="Calibri" pitchFamily="34" charset="-120"/>
-              </a:rPr>
-              <a:t> a </a:t>
-            </a:r>
-            <a:r>
-              <a:rPr lang="en-US" sz="900" i="1" dirty="0" err="1">
-                <a:solidFill>
-                  <a:srgbClr val="6E7B70"/>
-                </a:solidFill>
-                <a:latin typeface="Calibri" pitchFamily="34" charset="0"/>
-                <a:ea typeface="Calibri" pitchFamily="34" charset="-122"/>
-                <a:cs typeface="Calibri" pitchFamily="34" charset="-120"/>
-              </a:rPr>
-              <a:t>escolha</a:t>
-            </a:r>
-            <a:r>
-              <a:rPr lang="en-US" sz="900" i="1" dirty="0">
-                <a:solidFill>
-                  <a:srgbClr val="6E7B70"/>
-                </a:solidFill>
-                <a:latin typeface="Calibri" pitchFamily="34" charset="0"/>
-                <a:ea typeface="Calibri" pitchFamily="34" charset="-122"/>
-                <a:cs typeface="Calibri" pitchFamily="34" charset="-120"/>
-              </a:rPr>
-              <a:t>, </a:t>
-            </a:r>
-            <a:r>
-              <a:rPr lang="en-US" sz="900" i="1" dirty="0" err="1">
-                <a:solidFill>
-                  <a:srgbClr val="6E7B70"/>
-                </a:solidFill>
-                <a:latin typeface="Calibri" pitchFamily="34" charset="0"/>
-                <a:ea typeface="Calibri" pitchFamily="34" charset="-122"/>
-                <a:cs typeface="Calibri" pitchFamily="34" charset="-120"/>
-              </a:rPr>
-              <a:t>não</a:t>
-            </a:r>
-            <a:r>
-              <a:rPr lang="en-US" sz="900" i="1" dirty="0">
-                <a:solidFill>
-                  <a:srgbClr val="6E7B70"/>
-                </a:solidFill>
-                <a:latin typeface="Calibri" pitchFamily="34" charset="0"/>
-                <a:ea typeface="Calibri" pitchFamily="34" charset="-122"/>
-                <a:cs typeface="Calibri" pitchFamily="34" charset="-120"/>
-              </a:rPr>
-              <a:t> é </a:t>
-            </a:r>
-            <a:r>
-              <a:rPr lang="en-US" sz="900" i="1" dirty="0" err="1">
-                <a:solidFill>
-                  <a:srgbClr val="6E7B70"/>
-                </a:solidFill>
-                <a:latin typeface="Calibri" pitchFamily="34" charset="0"/>
-                <a:ea typeface="Calibri" pitchFamily="34" charset="-122"/>
-                <a:cs typeface="Calibri" pitchFamily="34" charset="-120"/>
-              </a:rPr>
-              <a:t>orçamento</a:t>
-            </a:r>
-            <a:r>
-              <a:rPr lang="en-US" sz="900" i="1" dirty="0">
-                <a:solidFill>
-                  <a:srgbClr val="6E7B70"/>
-                </a:solidFill>
-                <a:latin typeface="Calibri" pitchFamily="34" charset="0"/>
-                <a:ea typeface="Calibri" pitchFamily="34" charset="-122"/>
-                <a:cs typeface="Calibri" pitchFamily="34" charset="-120"/>
-              </a:rPr>
-              <a:t> </a:t>
-            </a:r>
-            <a:r>
-              <a:rPr lang="en-US" sz="900" i="1" dirty="0" err="1">
-                <a:solidFill>
-                  <a:srgbClr val="6E7B70"/>
-                </a:solidFill>
-                <a:latin typeface="Calibri" pitchFamily="34" charset="0"/>
-                <a:ea typeface="Calibri" pitchFamily="34" charset="-122"/>
-                <a:cs typeface="Calibri" pitchFamily="34" charset="-120"/>
-              </a:rPr>
-              <a:t>fechado</a:t>
-            </a:r>
-            <a:r>
-              <a:rPr lang="en-US" sz="900" i="1" dirty="0">
-                <a:solidFill>
-                  <a:srgbClr val="6E7B70"/>
-                </a:solidFill>
-                <a:latin typeface="Calibri" pitchFamily="34" charset="0"/>
-                <a:ea typeface="Calibri" pitchFamily="34" charset="-122"/>
-                <a:cs typeface="Calibri" pitchFamily="34" charset="-120"/>
-              </a:rPr>
-              <a:t>.</a:t>
-            </a:r>
             <a:endParaRPr lang="en-US" sz="900" dirty="0"/>
           </a:p>
           <a:p>
@@ -7600,7 +7659,84 @@
                 <a:ea typeface="Arial" pitchFamily="34" charset="-122"/>
                 <a:cs typeface="Arial" pitchFamily="34" charset="-120"/>
               </a:rPr>
-              <a:t>Volume alto, perfil ainda distante do comprador industrial</a:t>
+              <a:t>Volume alto, </a:t>
+            </a:r>
+            <a:r>
+              <a:rPr lang="en-US" sz="2800" b="1" dirty="0" err="1">
+                <a:solidFill>
+                  <a:srgbClr val="132E14"/>
+                </a:solidFill>
+                <a:latin typeface="Arial" pitchFamily="34" charset="0"/>
+                <a:ea typeface="Arial" pitchFamily="34" charset="-122"/>
+                <a:cs typeface="Arial" pitchFamily="34" charset="-120"/>
+              </a:rPr>
+              <a:t>perfil</a:t>
+            </a:r>
+            <a:r>
+              <a:rPr lang="en-US" sz="2800" b="1" dirty="0">
+                <a:solidFill>
+                  <a:srgbClr val="132E14"/>
+                </a:solidFill>
+                <a:latin typeface="Arial" pitchFamily="34" charset="0"/>
+                <a:ea typeface="Arial" pitchFamily="34" charset="-122"/>
+                <a:cs typeface="Arial" pitchFamily="34" charset="-120"/>
+              </a:rPr>
+              <a:t> </a:t>
+            </a:r>
+            <a:r>
+              <a:rPr lang="en-US" sz="2800" b="1" dirty="0" err="1" smtClean="0">
+                <a:solidFill>
+                  <a:srgbClr val="132E14"/>
+                </a:solidFill>
+                <a:latin typeface="Arial" pitchFamily="34" charset="0"/>
+                <a:ea typeface="Arial" pitchFamily="34" charset="-122"/>
+                <a:cs typeface="Arial" pitchFamily="34" charset="-120"/>
+              </a:rPr>
+              <a:t>já</a:t>
+            </a:r>
+            <a:r>
+              <a:rPr lang="en-US" sz="2800" b="1" dirty="0" smtClean="0">
+                <a:solidFill>
+                  <a:srgbClr val="132E14"/>
+                </a:solidFill>
+                <a:latin typeface="Arial" pitchFamily="34" charset="0"/>
+                <a:ea typeface="Arial" pitchFamily="34" charset="-122"/>
+                <a:cs typeface="Arial" pitchFamily="34" charset="-120"/>
+              </a:rPr>
+              <a:t> </a:t>
+            </a:r>
+            <a:r>
+              <a:rPr lang="en-US" sz="2800" b="1" dirty="0" err="1" smtClean="0">
+                <a:solidFill>
+                  <a:srgbClr val="132E14"/>
+                </a:solidFill>
+                <a:latin typeface="Arial" pitchFamily="34" charset="0"/>
+                <a:ea typeface="Arial" pitchFamily="34" charset="-122"/>
+                <a:cs typeface="Arial" pitchFamily="34" charset="-120"/>
+              </a:rPr>
+              <a:t>melhor</a:t>
+            </a:r>
+            <a:r>
+              <a:rPr lang="en-US" sz="2800" b="1" dirty="0" smtClean="0">
+                <a:solidFill>
+                  <a:srgbClr val="132E14"/>
+                </a:solidFill>
+                <a:latin typeface="Arial" pitchFamily="34" charset="0"/>
+                <a:ea typeface="Arial" pitchFamily="34" charset="-122"/>
+                <a:cs typeface="Arial" pitchFamily="34" charset="-120"/>
+              </a:rPr>
+              <a:t> </a:t>
+            </a:r>
+            <a:r>
+              <a:rPr lang="en-US" sz="2800" b="1" dirty="0" err="1" smtClean="0">
+                <a:solidFill>
+                  <a:srgbClr val="132E14"/>
+                </a:solidFill>
+                <a:latin typeface="Arial" pitchFamily="34" charset="0"/>
+                <a:ea typeface="Arial" pitchFamily="34" charset="-122"/>
+                <a:cs typeface="Arial" pitchFamily="34" charset="-120"/>
+              </a:rPr>
+              <a:t>direcionado</a:t>
             </a:r>
             <a:endParaRPr lang="en-US" sz="2900" dirty="0"/>
           </a:p>
@@ -7656,6 +7792,13 @@
             <a:prstDash val="solid"/>
           </a:ln>
         </p:spPr>
+        <p:txBody>
+          <a:bodyPr/>
+          <a:lstStyle/>
+          <a:p>
+            <a:endParaRPr/>
+          </a:p>
+        </p:txBody>
       </p:sp>
       <p:sp>
         <p:nvSpPr>
@@ -7690,7 +7833,7 @@
                 <a:ea typeface="Arial" pitchFamily="34" charset="-122"/>
                 <a:cs typeface="Arial" pitchFamily="34" charset="-120"/>
               </a:rPr>
-              <a:t>18%</a:t>
+              <a:t>25%</a:t>
             </a:r>
             <a:endParaRPr lang="en-US" sz="2800" dirty="0"/>
           </a:p>
@@ -7729,7 +7872,7 @@
                 <a:ea typeface="Calibri" pitchFamily="34" charset="-122"/>
                 <a:cs typeface="Calibri" pitchFamily="34" charset="-120"/>
               </a:rPr>
-              <a:t>dos leads pagos têm email corporativo próprio (6 de 33)</a:t>
+              <a:t>dos leads pagos têm email corporativo próprio (11 de 44)</a:t>
             </a:r>
             <a:endParaRPr lang="en-US" sz="1050" dirty="0"/>
           </a:p>
@@ -7761,6 +7904,13 @@
             <a:prstDash val="solid"/>
           </a:ln>
         </p:spPr>
+        <p:txBody>
+          <a:bodyPr/>
+          <a:lstStyle/>
+          <a:p>
+            <a:endParaRPr/>
+          </a:p>
+        </p:txBody>
       </p:sp>
       <p:sp>
         <p:nvSpPr>
@@ -7795,7 +7945,7 @@
                 <a:ea typeface="Arial" pitchFamily="34" charset="-122"/>
                 <a:cs typeface="Arial" pitchFamily="34" charset="-120"/>
               </a:rPr>
-              <a:t>63%</a:t>
+              <a:t>62%</a:t>
             </a:r>
             <a:endParaRPr lang="en-US" sz="2800" dirty="0"/>
           </a:p>
@@ -7834,7 +7984,7 @@
                 <a:ea typeface="Calibri" pitchFamily="34" charset="-122"/>
                 <a:cs typeface="Calibri" pitchFamily="34" charset="-120"/>
               </a:rPr>
-              <a:t>declararam estar "apenas explorando" no formulário</a:t>
+              <a:t>declararam estar "apenas explorando" no formulário (24 de 39 no Meta)</a:t>
             </a:r>
             <a:endParaRPr lang="en-US" sz="1050" dirty="0"/>
           </a:p>
@@ -7866,6 +8016,13 @@
             <a:prstDash val="solid"/>
           </a:ln>
         </p:spPr>
+        <p:txBody>
+          <a:bodyPr/>
+          <a:lstStyle/>
+          <a:p>
+            <a:endParaRPr/>
+          </a:p>
+        </p:txBody>
       </p:sp>
       <p:sp>
         <p:nvSpPr>
@@ -7892,15 +8049,14 @@
               <a:buNone/>
             </a:pPr>
             <a:r>
-              <a:rPr lang="en-US" sz="2800" b="1" dirty="0">
+              <a:rPr lang="en-US" sz="2800" b="1" dirty="0" smtClean="0">
                 <a:solidFill>
                   <a:srgbClr val="67836C"/>
                 </a:solidFill>
                 <a:latin typeface="Arial" pitchFamily="34" charset="0"/>
-                <a:ea typeface="Arial" pitchFamily="34" charset="-122"/>
                 <a:cs typeface="Arial" pitchFamily="34" charset="-120"/>
               </a:rPr>
-              <a:t>5</a:t>
+              <a:t>10</a:t>
             </a:r>
             <a:endParaRPr lang="en-US" sz="2800" dirty="0"/>
           </a:p>
@@ -7971,6 +8127,13 @@
             <a:prstDash val="solid"/>
           </a:ln>
         </p:spPr>
+        <p:txBody>
+          <a:bodyPr/>
+          <a:lstStyle/>
+          <a:p>
+            <a:endParaRPr/>
+          </a:p>
+        </p:txBody>
       </p:sp>
       <p:sp>
         <p:nvSpPr>
@@ -7980,7 +8143,7 @@
         </p:nvSpPr>
         <p:spPr>
           <a:xfrm>
-            <a:off x="822960" y="3218688"/>
+            <a:off x="822960" y="3145083"/>
             <a:ext cx="4846320" cy="274320"/>
           </a:xfrm>
           <a:prstGeom prst="rect">
@@ -8005,7 +8168,106 @@
                 <a:ea typeface="Arial" pitchFamily="34" charset="-122"/>
                 <a:cs typeface="Arial" pitchFamily="34" charset="-120"/>
               </a:rPr>
-              <a:t>V2  •  formulário que rodou em julho</a:t>
+              <a:t>V2  •  formulário que </a:t>
+            </a:r>
+            <a:r>
+              <a:rPr lang="en-US" sz="1300" b="1" dirty="0" err="1">
+                <a:solidFill>
+                  <a:srgbClr val="6E7B70"/>
+                </a:solidFill>
+                <a:latin typeface="Arial" pitchFamily="34" charset="0"/>
+                <a:ea typeface="Arial" pitchFamily="34" charset="-122"/>
+                <a:cs typeface="Arial" pitchFamily="34" charset="-120"/>
+              </a:rPr>
+              <a:t>rodou</a:t>
+            </a:r>
+            <a:r>
+              <a:rPr lang="en-US" sz="1300" b="1" dirty="0">
+                <a:solidFill>
+                  <a:srgbClr val="6E7B70"/>
+                </a:solidFill>
+                <a:latin typeface="Arial" pitchFamily="34" charset="0"/>
+                <a:ea typeface="Arial" pitchFamily="34" charset="-122"/>
+                <a:cs typeface="Arial" pitchFamily="34" charset="-120"/>
+              </a:rPr>
+              <a:t> </a:t>
+            </a:r>
+            <a:r>
+              <a:rPr lang="en-US" sz="1300" b="1" dirty="0" err="1" smtClean="0">
+                <a:solidFill>
+                  <a:srgbClr val="6E7B70"/>
+                </a:solidFill>
+                <a:latin typeface="Arial" pitchFamily="34" charset="0"/>
+                <a:ea typeface="Arial" pitchFamily="34" charset="-122"/>
+                <a:cs typeface="Arial" pitchFamily="34" charset="-120"/>
+              </a:rPr>
+              <a:t>na</a:t>
+            </a:r>
+            <a:r>
+              <a:rPr lang="en-US" sz="1300" b="1" dirty="0" smtClean="0">
+                <a:solidFill>
+                  <a:srgbClr val="6E7B70"/>
+                </a:solidFill>
+                <a:latin typeface="Arial" pitchFamily="34" charset="0"/>
+                <a:ea typeface="Arial" pitchFamily="34" charset="-122"/>
+                <a:cs typeface="Arial" pitchFamily="34" charset="-120"/>
+              </a:rPr>
+              <a:t> </a:t>
+            </a:r>
+            <a:r>
+              <a:rPr lang="en-US" sz="1300" b="1" dirty="0" err="1" smtClean="0">
+                <a:solidFill>
+                  <a:srgbClr val="6E7B70"/>
+                </a:solidFill>
+                <a:latin typeface="Arial" pitchFamily="34" charset="0"/>
+                <a:ea typeface="Arial" pitchFamily="34" charset="-122"/>
+                <a:cs typeface="Arial" pitchFamily="34" charset="-120"/>
+              </a:rPr>
+              <a:t>primeira</a:t>
+            </a:r>
+            <a:r>
+              <a:rPr lang="en-US" sz="1300" b="1" dirty="0" smtClean="0">
+                <a:solidFill>
+                  <a:srgbClr val="6E7B70"/>
+                </a:solidFill>
+                <a:latin typeface="Arial" pitchFamily="34" charset="0"/>
+                <a:ea typeface="Arial" pitchFamily="34" charset="-122"/>
+                <a:cs typeface="Arial" pitchFamily="34" charset="-120"/>
+              </a:rPr>
+              <a:t> </a:t>
+            </a:r>
+            <a:r>
+              <a:rPr lang="en-US" sz="1300" b="1" dirty="0" err="1" smtClean="0">
+                <a:solidFill>
+                  <a:srgbClr val="6E7B70"/>
+                </a:solidFill>
+                <a:latin typeface="Arial" pitchFamily="34" charset="0"/>
+                <a:ea typeface="Arial" pitchFamily="34" charset="-122"/>
+                <a:cs typeface="Arial" pitchFamily="34" charset="-120"/>
+              </a:rPr>
+              <a:t>quinzena</a:t>
+            </a:r>
+            <a:r>
+              <a:rPr lang="en-US" sz="1300" b="1" dirty="0" smtClean="0">
+                <a:solidFill>
+                  <a:srgbClr val="6E7B70"/>
+                </a:solidFill>
+                <a:latin typeface="Arial" pitchFamily="34" charset="0"/>
+                <a:ea typeface="Arial" pitchFamily="34" charset="-122"/>
+                <a:cs typeface="Arial" pitchFamily="34" charset="-120"/>
+              </a:rPr>
+              <a:t> de </a:t>
+            </a:r>
+            <a:r>
+              <a:rPr lang="en-US" sz="1300" b="1" dirty="0" err="1" smtClean="0">
+                <a:solidFill>
+                  <a:srgbClr val="6E7B70"/>
+                </a:solidFill>
+                <a:latin typeface="Arial" pitchFamily="34" charset="0"/>
+                <a:ea typeface="Arial" pitchFamily="34" charset="-122"/>
+                <a:cs typeface="Arial" pitchFamily="34" charset="-120"/>
+              </a:rPr>
+              <a:t>julho</a:t>
             </a:r>
             <a:endParaRPr lang="en-US" sz="1300" dirty="0"/>
           </a:p>
@@ -8134,7 +8396,73 @@
                 <a:ea typeface="Calibri" pitchFamily="34" charset="-122"/>
                 <a:cs typeface="Calibri" pitchFamily="34" charset="-120"/>
               </a:rPr>
-              <a:t>Cumpriu o objetivo: 30 leads em 11 dias. O preço foi o perfil</a:t>
+              <a:t>Cumpriu o objetivo: 27 leads </a:t>
+            </a:r>
+            <a:r>
+              <a:rPr lang="en-US" sz="1200" dirty="0" err="1">
+                <a:solidFill>
+                  <a:srgbClr val="2B332C"/>
+                </a:solidFill>
+                <a:latin typeface="Calibri" pitchFamily="34" charset="0"/>
+                <a:ea typeface="Calibri" pitchFamily="34" charset="-122"/>
+                <a:cs typeface="Calibri" pitchFamily="34" charset="-120"/>
+              </a:rPr>
+              <a:t>nos</a:t>
+            </a:r>
+            <a:r>
+              <a:rPr lang="en-US" sz="1200" dirty="0">
+                <a:solidFill>
+                  <a:srgbClr val="2B332C"/>
+                </a:solidFill>
+                <a:latin typeface="Calibri" pitchFamily="34" charset="0"/>
+                <a:ea typeface="Calibri" pitchFamily="34" charset="-122"/>
+                <a:cs typeface="Calibri" pitchFamily="34" charset="-120"/>
+              </a:rPr>
+              <a:t> </a:t>
+            </a:r>
+            <a:r>
+              <a:rPr lang="en-US" sz="1200" dirty="0" smtClean="0">
+                <a:solidFill>
+                  <a:srgbClr val="2B332C"/>
+                </a:solidFill>
+                <a:latin typeface="Calibri" pitchFamily="34" charset="0"/>
+                <a:ea typeface="Calibri" pitchFamily="34" charset="-122"/>
+                <a:cs typeface="Calibri" pitchFamily="34" charset="-120"/>
+              </a:rPr>
+              <a:t>EUA, </a:t>
+            </a:r>
+            <a:r>
+              <a:rPr lang="en-US" sz="1200" dirty="0" err="1" smtClean="0">
+                <a:solidFill>
+                  <a:srgbClr val="2B332C"/>
+                </a:solidFill>
+                <a:latin typeface="Calibri" pitchFamily="34" charset="0"/>
+                <a:ea typeface="Calibri" pitchFamily="34" charset="-122"/>
+                <a:cs typeface="Calibri" pitchFamily="34" charset="-120"/>
+              </a:rPr>
+              <a:t>apenas</a:t>
+            </a:r>
+            <a:r>
+              <a:rPr lang="en-US" sz="1200" dirty="0" smtClean="0">
+                <a:solidFill>
+                  <a:srgbClr val="2B332C"/>
+                </a:solidFill>
+                <a:latin typeface="Calibri" pitchFamily="34" charset="0"/>
+                <a:ea typeface="Calibri" pitchFamily="34" charset="-122"/>
+                <a:cs typeface="Calibri" pitchFamily="34" charset="-120"/>
+              </a:rPr>
+              <a:t> Meta, </a:t>
+            </a:r>
+            <a:r>
+              <a:rPr lang="en-US" sz="1200" dirty="0">
+                <a:solidFill>
+                  <a:srgbClr val="2B332C"/>
+                </a:solidFill>
+                <a:latin typeface="Calibri" pitchFamily="34" charset="0"/>
+                <a:ea typeface="Calibri" pitchFamily="34" charset="-122"/>
+                <a:cs typeface="Calibri" pitchFamily="34" charset="-120"/>
+              </a:rPr>
+              <a:t>em 12 dias. O preço foi o perfil</a:t>
             </a:r>
             <a:endParaRPr lang="en-US" sz="1200" dirty="0"/>
           </a:p>
@@ -8166,6 +8494,13 @@
             <a:prstDash val="solid"/>
           </a:ln>
         </p:spPr>
+        <p:txBody>
+          <a:bodyPr/>
+          <a:lstStyle/>
+          <a:p>
+            <a:endParaRPr/>
+          </a:p>
+        </p:txBody>
       </p:sp>
       <p:sp>
         <p:nvSpPr>
@@ -8175,7 +8510,7 @@
         </p:nvSpPr>
         <p:spPr>
           <a:xfrm>
-            <a:off x="6492240" y="3218688"/>
+            <a:off x="6492240" y="3140964"/>
             <a:ext cx="4846320" cy="274320"/>
           </a:xfrm>
           <a:prstGeom prst="rect">
@@ -8214,7 +8549,7 @@
         </p:nvSpPr>
         <p:spPr>
           <a:xfrm>
-            <a:off x="6492240" y="3493008"/>
+            <a:off x="6492240" y="3419403"/>
             <a:ext cx="4846320" cy="1143000"/>
           </a:xfrm>
           <a:prstGeom prst="rect">
@@ -8235,7 +8570,7 @@
               <a:buChar char="•"/>
             </a:pPr>
             <a:r>
-              <a:rPr lang="en-US" sz="1200" dirty="0" smtClean="0">
+              <a:rPr lang="en-US" sz="1100" dirty="0" smtClean="0">
                 <a:solidFill>
                   <a:srgbClr val="DDE3DB"/>
                 </a:solidFill>
@@ -8246,7 +8581,7 @@
               <a:t>Email </a:t>
             </a:r>
             <a:r>
-              <a:rPr lang="en-US" sz="1200" dirty="0">
+              <a:rPr lang="en-US" sz="1100" dirty="0" err="1" smtClean="0">
                 <a:solidFill>
                   <a:srgbClr val="DDE3DB"/>
                 </a:solidFill>
@@ -8254,10 +8589,10 @@
                 <a:ea typeface="Calibri" pitchFamily="34" charset="-122"/>
                 <a:cs typeface="Calibri" pitchFamily="34" charset="-120"/>
               </a:rPr>
-              <a:t>corporativo obrigatório, com </a:t>
-            </a:r>
-            <a:r>
-              <a:rPr lang="en-US" sz="1200" dirty="0" err="1" smtClean="0">
+              <a:t>corporativo</a:t>
+            </a:r>
+            <a:r>
+              <a:rPr lang="en-US" sz="1100" dirty="0" smtClean="0">
                 <a:solidFill>
                   <a:srgbClr val="DDE3DB"/>
                 </a:solidFill>
@@ -8265,9 +8600,53 @@
                 <a:ea typeface="Calibri" pitchFamily="34" charset="-122"/>
                 <a:cs typeface="Calibri" pitchFamily="34" charset="-120"/>
               </a:rPr>
+              <a:t>, </a:t>
+            </a:r>
+            <a:r>
+              <a:rPr lang="en-US" sz="1100" dirty="0">
+                <a:solidFill>
+                  <a:srgbClr val="DDE3DB"/>
+                </a:solidFill>
+                <a:latin typeface="Calibri" pitchFamily="34" charset="0"/>
+                <a:ea typeface="Calibri" pitchFamily="34" charset="-122"/>
+                <a:cs typeface="Calibri" pitchFamily="34" charset="-120"/>
+              </a:rPr>
+              <a:t>com </a:t>
+            </a:r>
+            <a:r>
+              <a:rPr lang="en-US" sz="1100" dirty="0" err="1" smtClean="0">
+                <a:solidFill>
+                  <a:srgbClr val="DDE3DB"/>
+                </a:solidFill>
+                <a:latin typeface="Calibri" pitchFamily="34" charset="0"/>
+                <a:ea typeface="Calibri" pitchFamily="34" charset="-122"/>
+                <a:cs typeface="Calibri" pitchFamily="34" charset="-120"/>
+              </a:rPr>
               <a:t>verificação</a:t>
             </a:r>
-            <a:endParaRPr lang="en-US" sz="1200" dirty="0"/>
+            <a:r>
+              <a:rPr lang="en-US" sz="1100" dirty="0" smtClean="0">
+                <a:solidFill>
+                  <a:srgbClr val="DDE3DB"/>
+                </a:solidFill>
+                <a:latin typeface="Calibri" pitchFamily="34" charset="0"/>
+                <a:ea typeface="Calibri" pitchFamily="34" charset="-122"/>
+                <a:cs typeface="Calibri" pitchFamily="34" charset="-120"/>
+              </a:rPr>
+              <a:t> </a:t>
+            </a:r>
+            <a:r>
+              <a:rPr lang="en-US" sz="1100" dirty="0" err="1" smtClean="0">
+                <a:solidFill>
+                  <a:srgbClr val="DDE3DB"/>
+                </a:solidFill>
+                <a:latin typeface="Calibri" pitchFamily="34" charset="0"/>
+                <a:ea typeface="Calibri" pitchFamily="34" charset="-122"/>
+                <a:cs typeface="Calibri" pitchFamily="34" charset="-120"/>
+              </a:rPr>
+              <a:t>obrigatória</a:t>
+            </a:r>
+            <a:endParaRPr lang="en-US" sz="1100" dirty="0"/>
           </a:p>
           <a:p>
             <a:pPr marL="342900" indent="-342900">
@@ -8278,7 +8657,7 @@
               <a:buChar char="•"/>
             </a:pPr>
             <a:r>
-              <a:rPr lang="en-US" sz="1200" dirty="0">
+              <a:rPr lang="en-US" sz="1100" dirty="0">
                 <a:solidFill>
                   <a:srgbClr val="DDE3DB"/>
                 </a:solidFill>
@@ -8289,7 +8668,7 @@
               <a:t>Para </a:t>
             </a:r>
             <a:r>
-              <a:rPr lang="en-US" sz="1200" dirty="0" err="1">
+              <a:rPr lang="en-US" sz="1100" dirty="0" err="1">
                 <a:solidFill>
                   <a:srgbClr val="DDE3DB"/>
                 </a:solidFill>
@@ -8300,7 +8679,7 @@
               <a:t>aumentar</a:t>
             </a:r>
             <a:r>
-              <a:rPr lang="en-US" sz="1200" dirty="0">
+              <a:rPr lang="en-US" sz="1100" dirty="0">
                 <a:solidFill>
                   <a:srgbClr val="DDE3DB"/>
                 </a:solidFill>
@@ -8311,7 +8690,7 @@
               <a:t> a </a:t>
             </a:r>
             <a:r>
-              <a:rPr lang="en-US" sz="1200" dirty="0" err="1">
+              <a:rPr lang="en-US" sz="1100" dirty="0" err="1">
                 <a:solidFill>
                   <a:srgbClr val="DDE3DB"/>
                 </a:solidFill>
@@ -8322,7 +8701,7 @@
               <a:t>segmentação</a:t>
             </a:r>
             <a:r>
-              <a:rPr lang="en-US" sz="1200" dirty="0">
+              <a:rPr lang="en-US" sz="1100" dirty="0">
                 <a:solidFill>
                   <a:srgbClr val="DDE3DB"/>
                 </a:solidFill>
@@ -8333,7 +8712,7 @@
               <a:t> e </a:t>
             </a:r>
             <a:r>
-              <a:rPr lang="en-US" sz="1200" dirty="0" err="1">
+              <a:rPr lang="en-US" sz="1100" dirty="0" err="1">
                 <a:solidFill>
                   <a:srgbClr val="DDE3DB"/>
                 </a:solidFill>
@@ -8344,7 +8723,7 @@
               <a:t>avaliação</a:t>
             </a:r>
             <a:r>
-              <a:rPr lang="en-US" sz="1200" dirty="0">
+              <a:rPr lang="en-US" sz="1100" dirty="0">
                 <a:solidFill>
                   <a:srgbClr val="DDE3DB"/>
                 </a:solidFill>
@@ -8355,7 +8734,7 @@
               <a:t>, </a:t>
             </a:r>
             <a:r>
-              <a:rPr lang="en-US" sz="1200" dirty="0" err="1">
+              <a:rPr lang="en-US" sz="1100" dirty="0" err="1">
                 <a:solidFill>
                   <a:srgbClr val="DDE3DB"/>
                 </a:solidFill>
@@ -8366,7 +8745,7 @@
               <a:t>solicitado</a:t>
             </a:r>
             <a:r>
-              <a:rPr lang="en-US" sz="1200" dirty="0">
+              <a:rPr lang="en-US" sz="1100" dirty="0">
                 <a:solidFill>
                   <a:srgbClr val="DDE3DB"/>
                 </a:solidFill>
@@ -8377,7 +8756,7 @@
               <a:t> </a:t>
             </a:r>
             <a:r>
-              <a:rPr lang="en-US" sz="1200" dirty="0" err="1">
+              <a:rPr lang="en-US" sz="1100" dirty="0" err="1">
                 <a:solidFill>
                   <a:srgbClr val="DDE3DB"/>
                 </a:solidFill>
@@ -8388,7 +8767,7 @@
               <a:t>opcionalmente</a:t>
             </a:r>
             <a:r>
-              <a:rPr lang="en-US" sz="1200" dirty="0">
+              <a:rPr lang="en-US" sz="1100" dirty="0">
                 <a:solidFill>
                   <a:srgbClr val="DDE3DB"/>
                 </a:solidFill>
@@ -8399,7 +8778,7 @@
               <a:t> </a:t>
             </a:r>
             <a:r>
-              <a:rPr lang="en-US" sz="1200" dirty="0" err="1">
+              <a:rPr lang="en-US" sz="1100" dirty="0" err="1">
                 <a:solidFill>
                   <a:srgbClr val="DDE3DB"/>
                 </a:solidFill>
@@ -8410,7 +8789,7 @@
               <a:t>informar</a:t>
             </a:r>
             <a:r>
-              <a:rPr lang="en-US" sz="1200" dirty="0">
+              <a:rPr lang="en-US" sz="1100" dirty="0">
                 <a:solidFill>
                   <a:srgbClr val="DDE3DB"/>
                 </a:solidFill>
@@ -8421,7 +8800,7 @@
               <a:t> o site da </a:t>
             </a:r>
             <a:r>
-              <a:rPr lang="en-US" sz="1200" dirty="0" err="1">
+              <a:rPr lang="en-US" sz="1100" dirty="0" err="1">
                 <a:solidFill>
                   <a:srgbClr val="DDE3DB"/>
                 </a:solidFill>
@@ -8431,7 +8810,7 @@
               </a:rPr>
               <a:t>empresa</a:t>
             </a:r>
-            <a:endParaRPr lang="en-US" sz="1200" dirty="0">
+            <a:endParaRPr lang="en-US" sz="1100" dirty="0">
               <a:solidFill>
                 <a:srgbClr val="DDE3DB"/>
               </a:solidFill>
@@ -8449,7 +8828,7 @@
               <a:buChar char="•"/>
             </a:pPr>
             <a:r>
-              <a:rPr lang="en-US" sz="1200" dirty="0" smtClean="0">
+              <a:rPr lang="en-US" sz="1100" dirty="0" smtClean="0">
                 <a:solidFill>
                   <a:srgbClr val="DDE3DB"/>
                 </a:solidFill>
@@ -8460,7 +8839,7 @@
               <a:t>Barra </a:t>
             </a:r>
             <a:r>
-              <a:rPr lang="en-US" sz="1200" dirty="0">
+              <a:rPr lang="en-US" sz="1100" dirty="0">
                 <a:solidFill>
                   <a:srgbClr val="DDE3DB"/>
                 </a:solidFill>
@@ -8470,7 +8849,7 @@
               </a:rPr>
               <a:t>contato sem empresa e preenchimento automatizado</a:t>
             </a:r>
-            <a:endParaRPr lang="en-US" sz="1200" dirty="0"/>
+            <a:endParaRPr lang="en-US" sz="1100" dirty="0"/>
           </a:p>
           <a:p>
             <a:pPr marL="342900" indent="-342900">
@@ -8482,7 +8861,7 @@
               <a:buChar char="•"/>
             </a:pPr>
             <a:r>
-              <a:rPr lang="en-US" sz="1200" dirty="0">
+              <a:rPr lang="en-US" sz="1100" dirty="0">
                 <a:solidFill>
                   <a:srgbClr val="DDE3DB"/>
                 </a:solidFill>
@@ -8490,10 +8869,10 @@
                 <a:ea typeface="Calibri" pitchFamily="34" charset="-122"/>
                 <a:cs typeface="Calibri" pitchFamily="34" charset="-120"/>
               </a:rPr>
-              <a:t>O volume de leads </a:t>
-            </a:r>
-            <a:r>
-              <a:rPr lang="en-US" sz="1200" dirty="0" err="1">
+              <a:t>Primeira leitura em 7 dias: o volume caiu e o </a:t>
+            </a:r>
+            <a:r>
+              <a:rPr lang="en-US" sz="1100" dirty="0" err="1">
                 <a:solidFill>
                   <a:srgbClr val="DDE3DB"/>
                 </a:solidFill>
@@ -8501,10 +8880,10 @@
                 <a:ea typeface="Calibri" pitchFamily="34" charset="-122"/>
                 <a:cs typeface="Calibri" pitchFamily="34" charset="-120"/>
               </a:rPr>
-              <a:t>deve</a:t>
-            </a:r>
-            <a:r>
-              <a:rPr lang="en-US" sz="1200" dirty="0">
+              <a:t>perfil</a:t>
+            </a:r>
+            <a:r>
+              <a:rPr lang="en-US" sz="1100" dirty="0">
                 <a:solidFill>
                   <a:srgbClr val="DDE3DB"/>
                 </a:solidFill>
@@ -8515,7 +8894,7 @@
               <a:t> </a:t>
             </a:r>
             <a:r>
-              <a:rPr lang="en-US" sz="1200" dirty="0" err="1">
+              <a:rPr lang="en-US" sz="1100" dirty="0" err="1" smtClean="0">
                 <a:solidFill>
                   <a:srgbClr val="DDE3DB"/>
                 </a:solidFill>
@@ -8523,10 +8902,10 @@
                 <a:ea typeface="Calibri" pitchFamily="34" charset="-122"/>
                 <a:cs typeface="Calibri" pitchFamily="34" charset="-120"/>
               </a:rPr>
-              <a:t>cair</a:t>
-            </a:r>
-            <a:r>
-              <a:rPr lang="en-US" sz="1200" dirty="0">
+              <a:t>subiu</a:t>
+            </a:r>
+            <a:r>
+              <a:rPr lang="en-US" sz="1100" dirty="0" smtClean="0">
                 <a:solidFill>
                   <a:srgbClr val="DDE3DB"/>
                 </a:solidFill>
@@ -8534,10 +8913,10 @@
                 <a:ea typeface="Calibri" pitchFamily="34" charset="-122"/>
                 <a:cs typeface="Calibri" pitchFamily="34" charset="-120"/>
               </a:rPr>
-              <a:t>. </a:t>
-            </a:r>
-            <a:r>
-              <a:rPr lang="en-US" sz="1200" dirty="0" err="1">
+              <a:t> (</a:t>
+            </a:r>
+            <a:r>
+              <a:rPr lang="en-US" sz="1100" dirty="0" err="1" smtClean="0">
                 <a:solidFill>
                   <a:srgbClr val="DDE3DB"/>
                 </a:solidFill>
@@ -8545,10 +8924,10 @@
                 <a:ea typeface="Calibri" pitchFamily="34" charset="-122"/>
                 <a:cs typeface="Calibri" pitchFamily="34" charset="-120"/>
               </a:rPr>
-              <a:t>Isso</a:t>
-            </a:r>
-            <a:r>
-              <a:rPr lang="en-US" sz="1200" dirty="0">
+              <a:t>ver</a:t>
+            </a:r>
+            <a:r>
+              <a:rPr lang="en-US" sz="1100" dirty="0" smtClean="0">
                 <a:solidFill>
                   <a:srgbClr val="DDE3DB"/>
                 </a:solidFill>
@@ -8556,10 +8935,10 @@
                 <a:ea typeface="Calibri" pitchFamily="34" charset="-122"/>
                 <a:cs typeface="Calibri" pitchFamily="34" charset="-120"/>
               </a:rPr>
-              <a:t> é </a:t>
-            </a:r>
-            <a:r>
-              <a:rPr lang="en-US" sz="1200" dirty="0" err="1">
+              <a:t> </a:t>
+            </a:r>
+            <a:r>
+              <a:rPr lang="en-US" sz="1100" dirty="0" err="1">
                 <a:solidFill>
                   <a:srgbClr val="DDE3DB"/>
                 </a:solidFill>
@@ -8567,10 +8946,10 @@
                 <a:ea typeface="Calibri" pitchFamily="34" charset="-122"/>
                 <a:cs typeface="Calibri" pitchFamily="34" charset="-120"/>
               </a:rPr>
-              <a:t>esperado</a:t>
-            </a:r>
-            <a:r>
-              <a:rPr lang="en-US" sz="1200" dirty="0">
+              <a:t>faixa</a:t>
+            </a:r>
+            <a:r>
+              <a:rPr lang="en-US" sz="1100" dirty="0">
                 <a:solidFill>
                   <a:srgbClr val="DDE3DB"/>
                 </a:solidFill>
@@ -8578,10 +8957,10 @@
                 <a:ea typeface="Calibri" pitchFamily="34" charset="-122"/>
                 <a:cs typeface="Calibri" pitchFamily="34" charset="-120"/>
               </a:rPr>
-              <a:t> e </a:t>
-            </a:r>
-            <a:r>
-              <a:rPr lang="en-US" sz="1200" dirty="0" err="1">
+              <a:t> </a:t>
+            </a:r>
+            <a:r>
+              <a:rPr lang="en-US" sz="1100" dirty="0" err="1" smtClean="0">
                 <a:solidFill>
                   <a:srgbClr val="DDE3DB"/>
                 </a:solidFill>
@@ -8589,25 +8968,19 @@
                 <a:ea typeface="Calibri" pitchFamily="34" charset="-122"/>
                 <a:cs typeface="Calibri" pitchFamily="34" charset="-120"/>
               </a:rPr>
-              <a:t>desejado</a:t>
-            </a:r>
-            <a:endParaRPr lang="en-US" sz="1200" dirty="0">
-              <a:solidFill>
-                <a:srgbClr val="DDE3DB"/>
-              </a:solidFill>
-              <a:latin typeface="Calibri" pitchFamily="34" charset="0"/>
-              <a:ea typeface="Calibri" pitchFamily="34" charset="-122"/>
-              <a:cs typeface="Calibri" pitchFamily="34" charset="-120"/>
-            </a:endParaRPr>
-          </a:p>
-          <a:p>
-            <a:pPr marL="342900" indent="-342900">
-              <a:spcAft>
-                <a:spcPts val="600"/>
-              </a:spcAft>
-              <a:buSzPct val="100000"/>
-              <a:buChar char="•"/>
-            </a:pPr>
+              <a:t>abaixo</a:t>
+            </a:r>
+            <a:r>
+              <a:rPr lang="en-US" sz="1100" dirty="0" smtClean="0">
+                <a:solidFill>
+                  <a:srgbClr val="DDE3DB"/>
+                </a:solidFill>
+                <a:latin typeface="Calibri" pitchFamily="34" charset="0"/>
+                <a:ea typeface="Calibri" pitchFamily="34" charset="-122"/>
+                <a:cs typeface="Calibri" pitchFamily="34" charset="-120"/>
+              </a:rPr>
+              <a:t>)</a:t>
+            </a:r>
             <a:r>
               <a:rPr lang="en-US" sz="1200" dirty="0" smtClean="0">
                 <a:solidFill>
@@ -8659,6 +9032,13 @@
             <a:prstDash val="solid"/>
           </a:ln>
         </p:spPr>
+        <p:txBody>
+          <a:bodyPr/>
+          <a:lstStyle/>
+          <a:p>
+            <a:endParaRPr/>
+          </a:p>
+        </p:txBody>
       </p:sp>
       <p:sp>
         <p:nvSpPr>
@@ -8695,931 +9075,7 @@
                 <a:ea typeface="Calibri" pitchFamily="34" charset="-122"/>
                 <a:cs typeface="Calibri" pitchFamily="34" charset="-120"/>
               </a:rPr>
-              <a:t>O que </a:t>
-            </a:r>
-            <a:r>
-              <a:rPr lang="en-US" sz="1200" b="1" dirty="0" err="1">
-                <a:solidFill>
-                  <a:srgbClr val="132E14"/>
-                </a:solidFill>
-                <a:latin typeface="Calibri" pitchFamily="34" charset="0"/>
-                <a:ea typeface="Calibri" pitchFamily="34" charset="-122"/>
-                <a:cs typeface="Calibri" pitchFamily="34" charset="-120"/>
-              </a:rPr>
-              <a:t>muda</a:t>
-            </a:r>
-            <a:r>
-              <a:rPr lang="en-US" sz="1200" b="1" dirty="0">
-                <a:solidFill>
-                  <a:srgbClr val="132E14"/>
-                </a:solidFill>
-                <a:latin typeface="Calibri" pitchFamily="34" charset="0"/>
-                <a:ea typeface="Calibri" pitchFamily="34" charset="-122"/>
-                <a:cs typeface="Calibri" pitchFamily="34" charset="-120"/>
-              </a:rPr>
-              <a:t> a </a:t>
-            </a:r>
-            <a:r>
-              <a:rPr lang="en-US" sz="1200" b="1" dirty="0" err="1">
-                <a:solidFill>
-                  <a:srgbClr val="132E14"/>
-                </a:solidFill>
-                <a:latin typeface="Calibri" pitchFamily="34" charset="0"/>
-                <a:ea typeface="Calibri" pitchFamily="34" charset="-122"/>
-                <a:cs typeface="Calibri" pitchFamily="34" charset="-120"/>
-              </a:rPr>
-              <a:t>partir</a:t>
-            </a:r>
-            <a:r>
-              <a:rPr lang="en-US" sz="1200" b="1" dirty="0">
-                <a:solidFill>
-                  <a:srgbClr val="132E14"/>
-                </a:solidFill>
-                <a:latin typeface="Calibri" pitchFamily="34" charset="0"/>
-                <a:ea typeface="Calibri" pitchFamily="34" charset="-122"/>
-                <a:cs typeface="Calibri" pitchFamily="34" charset="-120"/>
-              </a:rPr>
-              <a:t> de </a:t>
-            </a:r>
-            <a:r>
-              <a:rPr lang="en-US" sz="1200" b="1" dirty="0" smtClean="0">
-                <a:solidFill>
-                  <a:srgbClr val="132E14"/>
-                </a:solidFill>
-                <a:latin typeface="Calibri" pitchFamily="34" charset="0"/>
-                <a:ea typeface="Calibri" pitchFamily="34" charset="-122"/>
-                <a:cs typeface="Calibri" pitchFamily="34" charset="-120"/>
-              </a:rPr>
-              <a:t>agora: </a:t>
-            </a:r>
-            <a:r>
-              <a:rPr lang="en-US" sz="1200" dirty="0" err="1" smtClean="0">
-                <a:solidFill>
-                  <a:srgbClr val="2B332C"/>
-                </a:solidFill>
-                <a:latin typeface="Calibri" pitchFamily="34" charset="0"/>
-                <a:ea typeface="Calibri" pitchFamily="34" charset="-122"/>
-                <a:cs typeface="Calibri" pitchFamily="34" charset="-120"/>
-              </a:rPr>
-              <a:t>trocamos</a:t>
-            </a:r>
-            <a:r>
-              <a:rPr lang="en-US" sz="1200" dirty="0" smtClean="0">
-                <a:solidFill>
-                  <a:srgbClr val="2B332C"/>
-                </a:solidFill>
-                <a:latin typeface="Calibri" pitchFamily="34" charset="0"/>
-                <a:ea typeface="Calibri" pitchFamily="34" charset="-122"/>
-                <a:cs typeface="Calibri" pitchFamily="34" charset="-120"/>
-              </a:rPr>
-              <a:t> </a:t>
-            </a:r>
-            <a:r>
-              <a:rPr lang="en-US" sz="1200" dirty="0">
-                <a:solidFill>
-                  <a:srgbClr val="2B332C"/>
-                </a:solidFill>
-                <a:latin typeface="Calibri" pitchFamily="34" charset="0"/>
-                <a:ea typeface="Calibri" pitchFamily="34" charset="-122"/>
-                <a:cs typeface="Calibri" pitchFamily="34" charset="-120"/>
-              </a:rPr>
-              <a:t>volume </a:t>
-            </a:r>
-            <a:r>
-              <a:rPr lang="en-US" sz="1200" dirty="0" err="1">
-                <a:solidFill>
-                  <a:srgbClr val="2B332C"/>
-                </a:solidFill>
-                <a:latin typeface="Calibri" pitchFamily="34" charset="0"/>
-                <a:ea typeface="Calibri" pitchFamily="34" charset="-122"/>
-                <a:cs typeface="Calibri" pitchFamily="34" charset="-120"/>
-              </a:rPr>
-              <a:t>por</a:t>
-            </a:r>
-            <a:r>
-              <a:rPr lang="en-US" sz="1200" dirty="0">
-                <a:solidFill>
-                  <a:srgbClr val="2B332C"/>
-                </a:solidFill>
-                <a:latin typeface="Calibri" pitchFamily="34" charset="0"/>
-                <a:ea typeface="Calibri" pitchFamily="34" charset="-122"/>
-                <a:cs typeface="Calibri" pitchFamily="34" charset="-120"/>
-              </a:rPr>
-              <a:t> </a:t>
-            </a:r>
-            <a:r>
-              <a:rPr lang="en-US" sz="1200" dirty="0" err="1">
-                <a:solidFill>
-                  <a:srgbClr val="2B332C"/>
-                </a:solidFill>
-                <a:latin typeface="Calibri" pitchFamily="34" charset="0"/>
-                <a:ea typeface="Calibri" pitchFamily="34" charset="-122"/>
-                <a:cs typeface="Calibri" pitchFamily="34" charset="-120"/>
-              </a:rPr>
-              <a:t>perfil</a:t>
-            </a:r>
-            <a:r>
-              <a:rPr lang="en-US" sz="1200" dirty="0">
-                <a:solidFill>
-                  <a:srgbClr val="2B332C"/>
-                </a:solidFill>
-                <a:latin typeface="Calibri" pitchFamily="34" charset="0"/>
-                <a:ea typeface="Calibri" pitchFamily="34" charset="-122"/>
-                <a:cs typeface="Calibri" pitchFamily="34" charset="-120"/>
-              </a:rPr>
-              <a:t>, e a </a:t>
-            </a:r>
-            <a:r>
-              <a:rPr lang="en-US" sz="1200" dirty="0" err="1">
-                <a:solidFill>
-                  <a:srgbClr val="2B332C"/>
-                </a:solidFill>
-                <a:latin typeface="Calibri" pitchFamily="34" charset="0"/>
-                <a:ea typeface="Calibri" pitchFamily="34" charset="-122"/>
-                <a:cs typeface="Calibri" pitchFamily="34" charset="-120"/>
-              </a:rPr>
-              <a:t>verba</a:t>
-            </a:r>
-            <a:r>
-              <a:rPr lang="en-US" sz="1200" dirty="0">
-                <a:solidFill>
-                  <a:srgbClr val="2B332C"/>
-                </a:solidFill>
-                <a:latin typeface="Calibri" pitchFamily="34" charset="0"/>
-                <a:ea typeface="Calibri" pitchFamily="34" charset="-122"/>
-                <a:cs typeface="Calibri" pitchFamily="34" charset="-120"/>
-              </a:rPr>
-              <a:t> </a:t>
-            </a:r>
-            <a:r>
-              <a:rPr lang="en-US" sz="1200" dirty="0" err="1">
-                <a:solidFill>
-                  <a:srgbClr val="2B332C"/>
-                </a:solidFill>
-                <a:latin typeface="Calibri" pitchFamily="34" charset="0"/>
-                <a:ea typeface="Calibri" pitchFamily="34" charset="-122"/>
-                <a:cs typeface="Calibri" pitchFamily="34" charset="-120"/>
-              </a:rPr>
-              <a:t>volta</a:t>
-            </a:r>
-            <a:r>
-              <a:rPr lang="en-US" sz="1200" dirty="0">
-                <a:solidFill>
-                  <a:srgbClr val="2B332C"/>
-                </a:solidFill>
-                <a:latin typeface="Calibri" pitchFamily="34" charset="0"/>
-                <a:ea typeface="Calibri" pitchFamily="34" charset="-122"/>
-                <a:cs typeface="Calibri" pitchFamily="34" charset="-120"/>
-              </a:rPr>
-              <a:t> </a:t>
-            </a:r>
-            <a:r>
-              <a:rPr lang="en-US" sz="1200" dirty="0" err="1">
-                <a:solidFill>
-                  <a:srgbClr val="2B332C"/>
-                </a:solidFill>
-                <a:latin typeface="Calibri" pitchFamily="34" charset="0"/>
-                <a:ea typeface="Calibri" pitchFamily="34" charset="-122"/>
-                <a:cs typeface="Calibri" pitchFamily="34" charset="-120"/>
-              </a:rPr>
-              <a:t>ao</a:t>
-            </a:r>
-            <a:r>
-              <a:rPr lang="en-US" sz="1200" dirty="0">
-                <a:solidFill>
-                  <a:srgbClr val="2B332C"/>
-                </a:solidFill>
-                <a:latin typeface="Calibri" pitchFamily="34" charset="0"/>
-                <a:ea typeface="Calibri" pitchFamily="34" charset="-122"/>
-                <a:cs typeface="Calibri" pitchFamily="34" charset="-120"/>
-              </a:rPr>
-              <a:t> </a:t>
-            </a:r>
-            <a:r>
-              <a:rPr lang="en-US" sz="1200" dirty="0" err="1">
-                <a:solidFill>
-                  <a:srgbClr val="2B332C"/>
-                </a:solidFill>
-                <a:latin typeface="Calibri" pitchFamily="34" charset="0"/>
-                <a:ea typeface="Calibri" pitchFamily="34" charset="-122"/>
-                <a:cs typeface="Calibri" pitchFamily="34" charset="-120"/>
-              </a:rPr>
-              <a:t>teto</a:t>
-            </a:r>
-            <a:r>
-              <a:rPr lang="en-US" sz="1200" dirty="0">
-                <a:solidFill>
-                  <a:srgbClr val="2B332C"/>
-                </a:solidFill>
-                <a:latin typeface="Calibri" pitchFamily="34" charset="0"/>
-                <a:ea typeface="Calibri" pitchFamily="34" charset="-122"/>
-                <a:cs typeface="Calibri" pitchFamily="34" charset="-120"/>
-              </a:rPr>
-              <a:t> real do </a:t>
-            </a:r>
-            <a:r>
-              <a:rPr lang="en-US" sz="1200" dirty="0" err="1">
-                <a:solidFill>
-                  <a:srgbClr val="2B332C"/>
-                </a:solidFill>
-                <a:latin typeface="Calibri" pitchFamily="34" charset="0"/>
-                <a:ea typeface="Calibri" pitchFamily="34" charset="-122"/>
-                <a:cs typeface="Calibri" pitchFamily="34" charset="-120"/>
-              </a:rPr>
-              <a:t>mês</a:t>
-            </a:r>
-            <a:r>
-              <a:rPr lang="en-US" sz="1200" dirty="0">
-                <a:solidFill>
-                  <a:srgbClr val="2B332C"/>
-                </a:solidFill>
-                <a:latin typeface="Calibri" pitchFamily="34" charset="0"/>
-                <a:ea typeface="Calibri" pitchFamily="34" charset="-122"/>
-                <a:cs typeface="Calibri" pitchFamily="34" charset="-120"/>
-              </a:rPr>
-              <a:t> </a:t>
-            </a:r>
-            <a:r>
-              <a:rPr lang="en-US" sz="1200" dirty="0" err="1">
-                <a:solidFill>
-                  <a:srgbClr val="2B332C"/>
-                </a:solidFill>
-                <a:latin typeface="Calibri" pitchFamily="34" charset="0"/>
-                <a:ea typeface="Calibri" pitchFamily="34" charset="-122"/>
-                <a:cs typeface="Calibri" pitchFamily="34" charset="-120"/>
-              </a:rPr>
-              <a:t>depois</a:t>
-            </a:r>
-            <a:r>
-              <a:rPr lang="en-US" sz="1200" dirty="0">
-                <a:solidFill>
-                  <a:srgbClr val="2B332C"/>
-                </a:solidFill>
-                <a:latin typeface="Calibri" pitchFamily="34" charset="0"/>
-                <a:ea typeface="Calibri" pitchFamily="34" charset="-122"/>
-                <a:cs typeface="Calibri" pitchFamily="34" charset="-120"/>
-              </a:rPr>
-              <a:t> de um </a:t>
-            </a:r>
-            <a:r>
-              <a:rPr lang="en-US" sz="1200" dirty="0" err="1">
-                <a:solidFill>
-                  <a:srgbClr val="2B332C"/>
-                </a:solidFill>
-                <a:latin typeface="Calibri" pitchFamily="34" charset="0"/>
-                <a:ea typeface="Calibri" pitchFamily="34" charset="-122"/>
-                <a:cs typeface="Calibri" pitchFamily="34" charset="-120"/>
-              </a:rPr>
-              <a:t>período</a:t>
-            </a:r>
-            <a:r>
-              <a:rPr lang="en-US" sz="1200" dirty="0">
-                <a:solidFill>
-                  <a:srgbClr val="2B332C"/>
-                </a:solidFill>
-                <a:latin typeface="Calibri" pitchFamily="34" charset="0"/>
-                <a:ea typeface="Calibri" pitchFamily="34" charset="-122"/>
-                <a:cs typeface="Calibri" pitchFamily="34" charset="-120"/>
-              </a:rPr>
-              <a:t> de </a:t>
-            </a:r>
-            <a:r>
-              <a:rPr lang="en-US" sz="1200" dirty="0" smtClean="0">
-                <a:solidFill>
-                  <a:srgbClr val="2B332C"/>
-                </a:solidFill>
-                <a:latin typeface="Calibri" pitchFamily="34" charset="0"/>
-                <a:ea typeface="Calibri" pitchFamily="34" charset="-122"/>
-                <a:cs typeface="Calibri" pitchFamily="34" charset="-120"/>
-              </a:rPr>
-              <a:t>testes </a:t>
-            </a:r>
-            <a:r>
-              <a:rPr lang="en-US" sz="1200" dirty="0" err="1">
-                <a:solidFill>
-                  <a:srgbClr val="2B332C"/>
-                </a:solidFill>
-                <a:latin typeface="Calibri" pitchFamily="34" charset="0"/>
-                <a:ea typeface="Calibri" pitchFamily="34" charset="-122"/>
-                <a:cs typeface="Calibri" pitchFamily="34" charset="-120"/>
-              </a:rPr>
-              <a:t>acima</a:t>
-            </a:r>
-            <a:r>
-              <a:rPr lang="en-US" sz="1200" dirty="0">
-                <a:solidFill>
-                  <a:srgbClr val="2B332C"/>
-                </a:solidFill>
-                <a:latin typeface="Calibri" pitchFamily="34" charset="0"/>
-                <a:ea typeface="Calibri" pitchFamily="34" charset="-122"/>
-                <a:cs typeface="Calibri" pitchFamily="34" charset="-120"/>
-              </a:rPr>
-              <a:t> do </a:t>
-            </a:r>
-            <a:r>
-              <a:rPr lang="en-US" sz="1200" dirty="0" err="1">
-                <a:solidFill>
-                  <a:srgbClr val="2B332C"/>
-                </a:solidFill>
-                <a:latin typeface="Calibri" pitchFamily="34" charset="0"/>
-                <a:ea typeface="Calibri" pitchFamily="34" charset="-122"/>
-                <a:cs typeface="Calibri" pitchFamily="34" charset="-120"/>
-              </a:rPr>
-              <a:t>orçamento</a:t>
-            </a:r>
-            <a:r>
-              <a:rPr lang="en-US" sz="1200" dirty="0">
-                <a:solidFill>
-                  <a:srgbClr val="2B332C"/>
-                </a:solidFill>
-                <a:latin typeface="Calibri" pitchFamily="34" charset="0"/>
-                <a:ea typeface="Calibri" pitchFamily="34" charset="-122"/>
-                <a:cs typeface="Calibri" pitchFamily="34" charset="-120"/>
-              </a:rPr>
-              <a:t> </a:t>
-            </a:r>
-            <a:r>
-              <a:rPr lang="en-US" sz="1200" dirty="0" err="1">
-                <a:solidFill>
-                  <a:srgbClr val="2B332C"/>
-                </a:solidFill>
-                <a:latin typeface="Calibri" pitchFamily="34" charset="0"/>
-                <a:ea typeface="Calibri" pitchFamily="34" charset="-122"/>
-                <a:cs typeface="Calibri" pitchFamily="34" charset="-120"/>
-              </a:rPr>
-              <a:t>nos</a:t>
-            </a:r>
-            <a:r>
-              <a:rPr lang="en-US" sz="1200" dirty="0">
-                <a:solidFill>
-                  <a:srgbClr val="2B332C"/>
-                </a:solidFill>
-                <a:latin typeface="Calibri" pitchFamily="34" charset="0"/>
-                <a:ea typeface="Calibri" pitchFamily="34" charset="-122"/>
-                <a:cs typeface="Calibri" pitchFamily="34" charset="-120"/>
-              </a:rPr>
-              <a:t> </a:t>
-            </a:r>
-            <a:r>
-              <a:rPr lang="en-US" sz="1200" dirty="0" err="1">
-                <a:solidFill>
-                  <a:srgbClr val="2B332C"/>
-                </a:solidFill>
-                <a:latin typeface="Calibri" pitchFamily="34" charset="0"/>
-                <a:ea typeface="Calibri" pitchFamily="34" charset="-122"/>
-                <a:cs typeface="Calibri" pitchFamily="34" charset="-120"/>
-              </a:rPr>
-              <a:t>primeiros</a:t>
-            </a:r>
-            <a:r>
-              <a:rPr lang="en-US" sz="1200" dirty="0">
-                <a:solidFill>
-                  <a:srgbClr val="2B332C"/>
-                </a:solidFill>
-                <a:latin typeface="Calibri" pitchFamily="34" charset="0"/>
-                <a:ea typeface="Calibri" pitchFamily="34" charset="-122"/>
-                <a:cs typeface="Calibri" pitchFamily="34" charset="-120"/>
-              </a:rPr>
-              <a:t> 14 </a:t>
-            </a:r>
-            <a:r>
-              <a:rPr lang="en-US" sz="1200" dirty="0" err="1">
-                <a:solidFill>
-                  <a:srgbClr val="2B332C"/>
-                </a:solidFill>
-                <a:latin typeface="Calibri" pitchFamily="34" charset="0"/>
-                <a:ea typeface="Calibri" pitchFamily="34" charset="-122"/>
-                <a:cs typeface="Calibri" pitchFamily="34" charset="-120"/>
-              </a:rPr>
-              <a:t>dias</a:t>
-            </a:r>
-            <a:r>
-              <a:rPr lang="en-US" sz="1200" dirty="0">
-                <a:solidFill>
-                  <a:srgbClr val="2B332C"/>
-                </a:solidFill>
-                <a:latin typeface="Calibri" pitchFamily="34" charset="0"/>
-                <a:ea typeface="Calibri" pitchFamily="34" charset="-122"/>
-                <a:cs typeface="Calibri" pitchFamily="34" charset="-120"/>
-              </a:rPr>
-              <a:t>. As </a:t>
-            </a:r>
-            <a:r>
-              <a:rPr lang="en-US" sz="1200" dirty="0" err="1">
-                <a:solidFill>
-                  <a:srgbClr val="2B332C"/>
-                </a:solidFill>
-                <a:latin typeface="Calibri" pitchFamily="34" charset="0"/>
-                <a:ea typeface="Calibri" pitchFamily="34" charset="-122"/>
-                <a:cs typeface="Calibri" pitchFamily="34" charset="-120"/>
-              </a:rPr>
-              <a:t>duas</a:t>
-            </a:r>
-            <a:r>
-              <a:rPr lang="en-US" sz="1200" dirty="0">
-                <a:solidFill>
-                  <a:srgbClr val="2B332C"/>
-                </a:solidFill>
-                <a:latin typeface="Calibri" pitchFamily="34" charset="0"/>
-                <a:ea typeface="Calibri" pitchFamily="34" charset="-122"/>
-                <a:cs typeface="Calibri" pitchFamily="34" charset="-120"/>
-              </a:rPr>
-              <a:t> </a:t>
-            </a:r>
-            <a:r>
-              <a:rPr lang="en-US" sz="1200" dirty="0" err="1">
-                <a:solidFill>
-                  <a:srgbClr val="2B332C"/>
-                </a:solidFill>
-                <a:latin typeface="Calibri" pitchFamily="34" charset="0"/>
-                <a:ea typeface="Calibri" pitchFamily="34" charset="-122"/>
-                <a:cs typeface="Calibri" pitchFamily="34" charset="-120"/>
-              </a:rPr>
-              <a:t>mudanças</a:t>
-            </a:r>
-            <a:r>
-              <a:rPr lang="en-US" sz="1200" dirty="0">
-                <a:solidFill>
-                  <a:srgbClr val="2B332C"/>
-                </a:solidFill>
-                <a:latin typeface="Calibri" pitchFamily="34" charset="0"/>
-                <a:ea typeface="Calibri" pitchFamily="34" charset="-122"/>
-                <a:cs typeface="Calibri" pitchFamily="34" charset="-120"/>
-              </a:rPr>
-              <a:t> </a:t>
-            </a:r>
-            <a:r>
-              <a:rPr lang="en-US" sz="1200" dirty="0" err="1">
-                <a:solidFill>
-                  <a:srgbClr val="2B332C"/>
-                </a:solidFill>
-                <a:latin typeface="Calibri" pitchFamily="34" charset="0"/>
-                <a:ea typeface="Calibri" pitchFamily="34" charset="-122"/>
-                <a:cs typeface="Calibri" pitchFamily="34" charset="-120"/>
-              </a:rPr>
-              <a:t>devem</a:t>
-            </a:r>
-            <a:r>
-              <a:rPr lang="en-US" sz="1200" dirty="0">
-                <a:solidFill>
-                  <a:srgbClr val="2B332C"/>
-                </a:solidFill>
-                <a:latin typeface="Calibri" pitchFamily="34" charset="0"/>
-                <a:ea typeface="Calibri" pitchFamily="34" charset="-122"/>
-                <a:cs typeface="Calibri" pitchFamily="34" charset="-120"/>
-              </a:rPr>
-              <a:t> </a:t>
-            </a:r>
-            <a:r>
-              <a:rPr lang="en-US" sz="1200" dirty="0" err="1">
-                <a:solidFill>
-                  <a:srgbClr val="2B332C"/>
-                </a:solidFill>
-                <a:latin typeface="Calibri" pitchFamily="34" charset="0"/>
-                <a:ea typeface="Calibri" pitchFamily="34" charset="-122"/>
-                <a:cs typeface="Calibri" pitchFamily="34" charset="-120"/>
-              </a:rPr>
-              <a:t>reduzir</a:t>
-            </a:r>
-            <a:r>
-              <a:rPr lang="en-US" sz="1200" dirty="0">
-                <a:solidFill>
-                  <a:srgbClr val="2B332C"/>
-                </a:solidFill>
-                <a:latin typeface="Calibri" pitchFamily="34" charset="0"/>
-                <a:ea typeface="Calibri" pitchFamily="34" charset="-122"/>
-                <a:cs typeface="Calibri" pitchFamily="34" charset="-120"/>
-              </a:rPr>
-              <a:t> </a:t>
-            </a:r>
-            <a:r>
-              <a:rPr lang="en-US" sz="1200" dirty="0" err="1" smtClean="0">
-                <a:solidFill>
-                  <a:srgbClr val="2B332C"/>
-                </a:solidFill>
-                <a:latin typeface="Calibri" pitchFamily="34" charset="0"/>
-                <a:ea typeface="Calibri" pitchFamily="34" charset="-122"/>
-                <a:cs typeface="Calibri" pitchFamily="34" charset="-120"/>
-              </a:rPr>
-              <a:t>significativamente</a:t>
-            </a:r>
-            <a:r>
-              <a:rPr lang="en-US" sz="1200" dirty="0" smtClean="0">
-                <a:solidFill>
-                  <a:srgbClr val="2B332C"/>
-                </a:solidFill>
-                <a:latin typeface="Calibri" pitchFamily="34" charset="0"/>
-                <a:ea typeface="Calibri" pitchFamily="34" charset="-122"/>
-                <a:cs typeface="Calibri" pitchFamily="34" charset="-120"/>
-              </a:rPr>
-              <a:t> o </a:t>
-            </a:r>
-            <a:r>
-              <a:rPr lang="en-US" sz="1200" dirty="0">
-                <a:solidFill>
-                  <a:srgbClr val="2B332C"/>
-                </a:solidFill>
-                <a:latin typeface="Calibri" pitchFamily="34" charset="0"/>
-                <a:ea typeface="Calibri" pitchFamily="34" charset="-122"/>
-                <a:cs typeface="Calibri" pitchFamily="34" charset="-120"/>
-              </a:rPr>
-              <a:t>volume de leads </a:t>
-            </a:r>
-            <a:r>
-              <a:rPr lang="en-US" sz="1200" dirty="0" err="1">
-                <a:solidFill>
-                  <a:srgbClr val="2B332C"/>
-                </a:solidFill>
-                <a:latin typeface="Calibri" pitchFamily="34" charset="0"/>
-                <a:ea typeface="Calibri" pitchFamily="34" charset="-122"/>
-                <a:cs typeface="Calibri" pitchFamily="34" charset="-120"/>
-              </a:rPr>
-              <a:t>nas</a:t>
-            </a:r>
-            <a:r>
-              <a:rPr lang="en-US" sz="1200" dirty="0">
-                <a:solidFill>
-                  <a:srgbClr val="2B332C"/>
-                </a:solidFill>
-                <a:latin typeface="Calibri" pitchFamily="34" charset="0"/>
-                <a:ea typeface="Calibri" pitchFamily="34" charset="-122"/>
-                <a:cs typeface="Calibri" pitchFamily="34" charset="-120"/>
-              </a:rPr>
-              <a:t> </a:t>
-            </a:r>
-            <a:r>
-              <a:rPr lang="en-US" sz="1200" dirty="0" err="1">
-                <a:solidFill>
-                  <a:srgbClr val="2B332C"/>
-                </a:solidFill>
-                <a:latin typeface="Calibri" pitchFamily="34" charset="0"/>
-                <a:ea typeface="Calibri" pitchFamily="34" charset="-122"/>
-                <a:cs typeface="Calibri" pitchFamily="34" charset="-120"/>
-              </a:rPr>
-              <a:t>próximas</a:t>
-            </a:r>
-            <a:r>
-              <a:rPr lang="en-US" sz="1200" dirty="0">
-                <a:solidFill>
-                  <a:srgbClr val="2B332C"/>
-                </a:solidFill>
-                <a:latin typeface="Calibri" pitchFamily="34" charset="0"/>
-                <a:ea typeface="Calibri" pitchFamily="34" charset="-122"/>
-                <a:cs typeface="Calibri" pitchFamily="34" charset="-120"/>
-              </a:rPr>
-              <a:t> </a:t>
-            </a:r>
-            <a:r>
-              <a:rPr lang="en-US" sz="1200" dirty="0" err="1">
-                <a:solidFill>
-                  <a:srgbClr val="2B332C"/>
-                </a:solidFill>
-                <a:latin typeface="Calibri" pitchFamily="34" charset="0"/>
-                <a:ea typeface="Calibri" pitchFamily="34" charset="-122"/>
-                <a:cs typeface="Calibri" pitchFamily="34" charset="-120"/>
-              </a:rPr>
-              <a:t>semanas</a:t>
-            </a:r>
-            <a:r>
-              <a:rPr lang="en-US" sz="1200" dirty="0">
-                <a:solidFill>
-                  <a:srgbClr val="2B332C"/>
-                </a:solidFill>
-                <a:latin typeface="Calibri" pitchFamily="34" charset="0"/>
-                <a:ea typeface="Calibri" pitchFamily="34" charset="-122"/>
-                <a:cs typeface="Calibri" pitchFamily="34" charset="-120"/>
-              </a:rPr>
-              <a:t>, </a:t>
-            </a:r>
-            <a:r>
-              <a:rPr lang="en-US" sz="1200" dirty="0" err="1">
-                <a:solidFill>
-                  <a:srgbClr val="2B332C"/>
-                </a:solidFill>
-                <a:latin typeface="Calibri" pitchFamily="34" charset="0"/>
-                <a:ea typeface="Calibri" pitchFamily="34" charset="-122"/>
-                <a:cs typeface="Calibri" pitchFamily="34" charset="-120"/>
-              </a:rPr>
-              <a:t>por</a:t>
-            </a:r>
-            <a:r>
-              <a:rPr lang="en-US" sz="1200" dirty="0">
-                <a:solidFill>
-                  <a:srgbClr val="2B332C"/>
-                </a:solidFill>
-                <a:latin typeface="Calibri" pitchFamily="34" charset="0"/>
-                <a:ea typeface="Calibri" pitchFamily="34" charset="-122"/>
-                <a:cs typeface="Calibri" pitchFamily="34" charset="-120"/>
-              </a:rPr>
-              <a:t> </a:t>
-            </a:r>
-            <a:r>
-              <a:rPr lang="en-US" sz="1200" dirty="0" err="1">
-                <a:solidFill>
-                  <a:srgbClr val="2B332C"/>
-                </a:solidFill>
-                <a:latin typeface="Calibri" pitchFamily="34" charset="0"/>
-                <a:ea typeface="Calibri" pitchFamily="34" charset="-122"/>
-                <a:cs typeface="Calibri" pitchFamily="34" charset="-120"/>
-              </a:rPr>
-              <a:t>desenho</a:t>
-            </a:r>
-            <a:r>
-              <a:rPr lang="en-US" sz="1200" dirty="0">
-                <a:solidFill>
-                  <a:srgbClr val="2B332C"/>
-                </a:solidFill>
-                <a:latin typeface="Calibri" pitchFamily="34" charset="0"/>
-                <a:ea typeface="Calibri" pitchFamily="34" charset="-122"/>
-                <a:cs typeface="Calibri" pitchFamily="34" charset="-120"/>
-              </a:rPr>
-              <a:t>, </a:t>
-            </a:r>
-            <a:r>
-              <a:rPr lang="en-US" sz="1200" dirty="0" err="1">
-                <a:solidFill>
-                  <a:srgbClr val="2B332C"/>
-                </a:solidFill>
-                <a:latin typeface="Calibri" pitchFamily="34" charset="0"/>
-                <a:ea typeface="Calibri" pitchFamily="34" charset="-122"/>
-                <a:cs typeface="Calibri" pitchFamily="34" charset="-120"/>
-              </a:rPr>
-              <a:t>não</a:t>
-            </a:r>
-            <a:r>
-              <a:rPr lang="en-US" sz="1200" dirty="0">
-                <a:solidFill>
-                  <a:srgbClr val="2B332C"/>
-                </a:solidFill>
-                <a:latin typeface="Calibri" pitchFamily="34" charset="0"/>
-                <a:ea typeface="Calibri" pitchFamily="34" charset="-122"/>
-                <a:cs typeface="Calibri" pitchFamily="34" charset="-120"/>
-              </a:rPr>
-              <a:t> </a:t>
-            </a:r>
-            <a:r>
-              <a:rPr lang="en-US" sz="1200" dirty="0" err="1">
-                <a:solidFill>
-                  <a:srgbClr val="2B332C"/>
-                </a:solidFill>
-                <a:latin typeface="Calibri" pitchFamily="34" charset="0"/>
-                <a:ea typeface="Calibri" pitchFamily="34" charset="-122"/>
-                <a:cs typeface="Calibri" pitchFamily="34" charset="-120"/>
-              </a:rPr>
-              <a:t>por</a:t>
-            </a:r>
-            <a:r>
-              <a:rPr lang="en-US" sz="1200" dirty="0">
-                <a:solidFill>
-                  <a:srgbClr val="2B332C"/>
-                </a:solidFill>
-                <a:latin typeface="Calibri" pitchFamily="34" charset="0"/>
-                <a:ea typeface="Calibri" pitchFamily="34" charset="-122"/>
-                <a:cs typeface="Calibri" pitchFamily="34" charset="-120"/>
-              </a:rPr>
-              <a:t> </a:t>
-            </a:r>
-            <a:r>
-              <a:rPr lang="en-US" sz="1200" dirty="0" err="1">
-                <a:solidFill>
-                  <a:srgbClr val="2B332C"/>
-                </a:solidFill>
-                <a:latin typeface="Calibri" pitchFamily="34" charset="0"/>
-                <a:ea typeface="Calibri" pitchFamily="34" charset="-122"/>
-                <a:cs typeface="Calibri" pitchFamily="34" charset="-120"/>
-              </a:rPr>
-              <a:t>perda</a:t>
-            </a:r>
-            <a:r>
-              <a:rPr lang="en-US" sz="1200" dirty="0">
-                <a:solidFill>
-                  <a:srgbClr val="2B332C"/>
-                </a:solidFill>
-                <a:latin typeface="Calibri" pitchFamily="34" charset="0"/>
-                <a:ea typeface="Calibri" pitchFamily="34" charset="-122"/>
-                <a:cs typeface="Calibri" pitchFamily="34" charset="-120"/>
-              </a:rPr>
-              <a:t> de performance. O </a:t>
-            </a:r>
-            <a:r>
-              <a:rPr lang="en-US" sz="1200" dirty="0" err="1">
-                <a:solidFill>
-                  <a:srgbClr val="2B332C"/>
-                </a:solidFill>
-                <a:latin typeface="Calibri" pitchFamily="34" charset="0"/>
-                <a:ea typeface="Calibri" pitchFamily="34" charset="-122"/>
-                <a:cs typeface="Calibri" pitchFamily="34" charset="-120"/>
-              </a:rPr>
-              <a:t>indicador</a:t>
-            </a:r>
-            <a:r>
-              <a:rPr lang="en-US" sz="1200" dirty="0">
-                <a:solidFill>
-                  <a:srgbClr val="2B332C"/>
-                </a:solidFill>
-                <a:latin typeface="Calibri" pitchFamily="34" charset="0"/>
-                <a:ea typeface="Calibri" pitchFamily="34" charset="-122"/>
-                <a:cs typeface="Calibri" pitchFamily="34" charset="-120"/>
-              </a:rPr>
-              <a:t> que </a:t>
-            </a:r>
-            <a:r>
-              <a:rPr lang="en-US" sz="1200" dirty="0" err="1">
-                <a:solidFill>
-                  <a:srgbClr val="2B332C"/>
-                </a:solidFill>
-                <a:latin typeface="Calibri" pitchFamily="34" charset="0"/>
-                <a:ea typeface="Calibri" pitchFamily="34" charset="-122"/>
-                <a:cs typeface="Calibri" pitchFamily="34" charset="-120"/>
-              </a:rPr>
-              <a:t>passa</a:t>
-            </a:r>
-            <a:r>
-              <a:rPr lang="en-US" sz="1200" dirty="0">
-                <a:solidFill>
-                  <a:srgbClr val="2B332C"/>
-                </a:solidFill>
-                <a:latin typeface="Calibri" pitchFamily="34" charset="0"/>
-                <a:ea typeface="Calibri" pitchFamily="34" charset="-122"/>
-                <a:cs typeface="Calibri" pitchFamily="34" charset="-120"/>
-              </a:rPr>
-              <a:t> a </a:t>
-            </a:r>
-            <a:r>
-              <a:rPr lang="en-US" sz="1200" dirty="0" err="1">
-                <a:solidFill>
-                  <a:srgbClr val="2B332C"/>
-                </a:solidFill>
-                <a:latin typeface="Calibri" pitchFamily="34" charset="0"/>
-                <a:ea typeface="Calibri" pitchFamily="34" charset="-122"/>
-                <a:cs typeface="Calibri" pitchFamily="34" charset="-120"/>
-              </a:rPr>
-              <a:t>valer</a:t>
-            </a:r>
-            <a:r>
-              <a:rPr lang="en-US" sz="1200" dirty="0">
-                <a:solidFill>
-                  <a:srgbClr val="2B332C"/>
-                </a:solidFill>
-                <a:latin typeface="Calibri" pitchFamily="34" charset="0"/>
-                <a:ea typeface="Calibri" pitchFamily="34" charset="-122"/>
-                <a:cs typeface="Calibri" pitchFamily="34" charset="-120"/>
-              </a:rPr>
-              <a:t> </a:t>
-            </a:r>
-            <a:r>
-              <a:rPr lang="en-US" sz="1200" dirty="0" err="1">
-                <a:solidFill>
-                  <a:srgbClr val="2B332C"/>
-                </a:solidFill>
-                <a:latin typeface="Calibri" pitchFamily="34" charset="0"/>
-                <a:ea typeface="Calibri" pitchFamily="34" charset="-122"/>
-                <a:cs typeface="Calibri" pitchFamily="34" charset="-120"/>
-              </a:rPr>
-              <a:t>não</a:t>
-            </a:r>
-            <a:r>
-              <a:rPr lang="en-US" sz="1200" dirty="0">
-                <a:solidFill>
-                  <a:srgbClr val="2B332C"/>
-                </a:solidFill>
-                <a:latin typeface="Calibri" pitchFamily="34" charset="0"/>
-                <a:ea typeface="Calibri" pitchFamily="34" charset="-122"/>
-                <a:cs typeface="Calibri" pitchFamily="34" charset="-120"/>
-              </a:rPr>
-              <a:t> é </a:t>
-            </a:r>
-            <a:r>
-              <a:rPr lang="en-US" sz="1200" dirty="0" err="1">
-                <a:solidFill>
-                  <a:srgbClr val="2B332C"/>
-                </a:solidFill>
-                <a:latin typeface="Calibri" pitchFamily="34" charset="0"/>
-                <a:ea typeface="Calibri" pitchFamily="34" charset="-122"/>
-                <a:cs typeface="Calibri" pitchFamily="34" charset="-120"/>
-              </a:rPr>
-              <a:t>quantos</a:t>
-            </a:r>
-            <a:r>
-              <a:rPr lang="en-US" sz="1200" dirty="0">
-                <a:solidFill>
-                  <a:srgbClr val="2B332C"/>
-                </a:solidFill>
-                <a:latin typeface="Calibri" pitchFamily="34" charset="0"/>
-                <a:ea typeface="Calibri" pitchFamily="34" charset="-122"/>
-                <a:cs typeface="Calibri" pitchFamily="34" charset="-120"/>
-              </a:rPr>
-              <a:t> leads </a:t>
-            </a:r>
-            <a:r>
-              <a:rPr lang="en-US" sz="1200" dirty="0" err="1">
-                <a:solidFill>
-                  <a:srgbClr val="2B332C"/>
-                </a:solidFill>
-                <a:latin typeface="Calibri" pitchFamily="34" charset="0"/>
-                <a:ea typeface="Calibri" pitchFamily="34" charset="-122"/>
-                <a:cs typeface="Calibri" pitchFamily="34" charset="-120"/>
-              </a:rPr>
-              <a:t>chegam</a:t>
-            </a:r>
-            <a:r>
-              <a:rPr lang="en-US" sz="1200" dirty="0">
-                <a:solidFill>
-                  <a:srgbClr val="2B332C"/>
-                </a:solidFill>
-                <a:latin typeface="Calibri" pitchFamily="34" charset="0"/>
-                <a:ea typeface="Calibri" pitchFamily="34" charset="-122"/>
-                <a:cs typeface="Calibri" pitchFamily="34" charset="-120"/>
-              </a:rPr>
-              <a:t>, e sim </a:t>
-            </a:r>
-            <a:r>
-              <a:rPr lang="en-US" sz="1200" dirty="0" err="1">
-                <a:solidFill>
-                  <a:srgbClr val="2B332C"/>
-                </a:solidFill>
-                <a:latin typeface="Calibri" pitchFamily="34" charset="0"/>
-                <a:ea typeface="Calibri" pitchFamily="34" charset="-122"/>
-                <a:cs typeface="Calibri" pitchFamily="34" charset="-120"/>
-              </a:rPr>
-              <a:t>quantos</a:t>
-            </a:r>
-            <a:r>
-              <a:rPr lang="en-US" sz="1200" dirty="0">
-                <a:solidFill>
-                  <a:srgbClr val="2B332C"/>
-                </a:solidFill>
-                <a:latin typeface="Calibri" pitchFamily="34" charset="0"/>
-                <a:ea typeface="Calibri" pitchFamily="34" charset="-122"/>
-                <a:cs typeface="Calibri" pitchFamily="34" charset="-120"/>
-              </a:rPr>
-              <a:t> o </a:t>
-            </a:r>
-            <a:r>
-              <a:rPr lang="en-US" sz="1200" dirty="0" err="1">
-                <a:solidFill>
-                  <a:srgbClr val="2B332C"/>
-                </a:solidFill>
-                <a:latin typeface="Calibri" pitchFamily="34" charset="0"/>
-                <a:ea typeface="Calibri" pitchFamily="34" charset="-122"/>
-                <a:cs typeface="Calibri" pitchFamily="34" charset="-120"/>
-              </a:rPr>
-              <a:t>comercial</a:t>
-            </a:r>
-            <a:r>
-              <a:rPr lang="en-US" sz="1200" dirty="0">
-                <a:solidFill>
-                  <a:srgbClr val="2B332C"/>
-                </a:solidFill>
-                <a:latin typeface="Calibri" pitchFamily="34" charset="0"/>
-                <a:ea typeface="Calibri" pitchFamily="34" charset="-122"/>
-                <a:cs typeface="Calibri" pitchFamily="34" charset="-120"/>
-              </a:rPr>
-              <a:t> </a:t>
-            </a:r>
-            <a:r>
-              <a:rPr lang="en-US" sz="1200" dirty="0" err="1">
-                <a:solidFill>
-                  <a:srgbClr val="2B332C"/>
-                </a:solidFill>
-                <a:latin typeface="Calibri" pitchFamily="34" charset="0"/>
-                <a:ea typeface="Calibri" pitchFamily="34" charset="-122"/>
-                <a:cs typeface="Calibri" pitchFamily="34" charset="-120"/>
-              </a:rPr>
-              <a:t>consegue</a:t>
-            </a:r>
-            <a:r>
-              <a:rPr lang="en-US" sz="1200" dirty="0">
-                <a:solidFill>
-                  <a:srgbClr val="2B332C"/>
-                </a:solidFill>
-                <a:latin typeface="Calibri" pitchFamily="34" charset="0"/>
-                <a:ea typeface="Calibri" pitchFamily="34" charset="-122"/>
-                <a:cs typeface="Calibri" pitchFamily="34" charset="-120"/>
-              </a:rPr>
-              <a:t> </a:t>
-            </a:r>
-            <a:r>
-              <a:rPr lang="en-US" sz="1200" dirty="0" err="1">
-                <a:solidFill>
-                  <a:srgbClr val="2B332C"/>
-                </a:solidFill>
-                <a:latin typeface="Calibri" pitchFamily="34" charset="0"/>
-                <a:ea typeface="Calibri" pitchFamily="34" charset="-122"/>
-                <a:cs typeface="Calibri" pitchFamily="34" charset="-120"/>
-              </a:rPr>
-              <a:t>trabalhar</a:t>
-            </a:r>
-            <a:r>
-              <a:rPr lang="en-US" sz="1200" dirty="0">
-                <a:solidFill>
-                  <a:srgbClr val="2B332C"/>
-                </a:solidFill>
-                <a:latin typeface="Calibri" pitchFamily="34" charset="0"/>
-                <a:ea typeface="Calibri" pitchFamily="34" charset="-122"/>
-                <a:cs typeface="Calibri" pitchFamily="34" charset="-120"/>
-              </a:rPr>
-              <a:t>.</a:t>
+              <a:t>O V3 respondeu em 7 dias. No mesmo conjunto dos EUA, o custo por lead subiu de R$ 50,58 para R$ 79,82 (+58%), mas a fatia de contatos com email de domínio próprio saltou de 15% para 83%, e a de quem declara intenção imediata ou nas próximas semanas foi de 7% para 50%. Na prática: o lead com email corporativo ficou 3,6 vezes mais barato e o lead quente, 4,3 vezes. São 6 leads em 7 dias, então é direção e ainda não série. O indicador que passa a valer não é quantos leads chegam, e sim quantos o comercial consegue trabalhar.</a:t>
             </a:r>
             <a:endParaRPr lang="en-US" sz="1400" dirty="0"/>
           </a:p>
@@ -9667,7 +9123,7 @@
                 <a:ea typeface="Calibri" pitchFamily="34" charset="-122"/>
                 <a:cs typeface="Calibri" pitchFamily="34" charset="-120"/>
               </a:rPr>
-              <a:t>Contatos com fit já identificados: Green Truth / Zingi Beverages (EUA), Malkmus Holistic (Alemanha), Oliver Wildheart, Natural Nirvana e Afriorganics (EUA).</a:t>
+              <a:t>Contatos com fit já identificados: Green Truth / Zingi Beverages, Oliver Wildheart, Natural Nirvana, Afriorganics (EUA), Malkmus Holistic (Alemanha) e, já pelo V3: American Shaman CBD, Afristocks e Saffyre LLC (EUA).</a:t>
             </a:r>
             <a:endParaRPr lang="en-US" sz="900" dirty="0"/>
           </a:p>
@@ -9848,7 +9304,7 @@
           <p:nvPr>
             <p:extLst>
               <p:ext uri="{D42A27DB-BD31-4B8C-83A1-F6EECF244321}">
-                <p14:modId xmlns:p14="http://schemas.microsoft.com/office/powerpoint/2010/main" val="2175709992"/>
+                <p14:modId xmlns:p14="http://schemas.microsoft.com/office/powerpoint/2010/main" val="1574160630"/>
               </p:ext>
             </p:extLst>
           </p:nvPr>
@@ -10180,10 +9636,21 @@
                           <a:ea typeface="Calibri" pitchFamily="34" charset="-122"/>
                           <a:cs typeface="Calibri" pitchFamily="34" charset="-120"/>
                         </a:rPr>
-                        <a:t>. Cliques, </a:t>
+                        <a:t>. </a:t>
                       </a:r>
                       <a:r>
-                        <a:rPr lang="en-US" sz="1050" dirty="0" err="1" smtClean="0">
+                        <a:rPr lang="en-US" sz="1050" b="1" dirty="0" smtClean="0">
+                          <a:solidFill>
+                            <a:srgbClr val="2B332C"/>
+                          </a:solidFill>
+                          <a:latin typeface="Calibri" pitchFamily="34" charset="0"/>
+                          <a:ea typeface="Calibri" pitchFamily="34" charset="-122"/>
+                          <a:cs typeface="Calibri" pitchFamily="34" charset="-120"/>
+                        </a:rPr>
+                        <a:t>Cliques, </a:t>
+                      </a:r>
+                      <a:r>
+                        <a:rPr lang="en-US" sz="1050" b="1" dirty="0" err="1" smtClean="0">
                           <a:solidFill>
                             <a:srgbClr val="2B332C"/>
                           </a:solidFill>
@@ -10194,7 +9661,7 @@
                         <a:t>não</a:t>
                       </a:r>
                       <a:r>
-                        <a:rPr lang="en-US" sz="1050" dirty="0" smtClean="0">
+                        <a:rPr lang="en-US" sz="1050" b="1" dirty="0" smtClean="0">
                           <a:solidFill>
                             <a:srgbClr val="2B332C"/>
                           </a:solidFill>
@@ -10204,7 +9671,7 @@
                         </a:rPr>
                         <a:t> leads.</a:t>
                       </a:r>
-                      <a:endParaRPr lang="en-US" sz="1050" dirty="0">
+                      <a:endParaRPr lang="en-US" sz="1050" b="1" dirty="0">
                         <a:latin typeface="Calibri" charset="0"/>
                         <a:ea typeface="Calibri" charset="0"/>
                         <a:cs typeface="Calibri" charset="0"/>
@@ -10262,6 +9729,17 @@
                         <a:buNone/>
                       </a:pPr>
                       <a:r>
+                        <a:rPr lang="en-US" sz="1050" dirty="0" smtClean="0">
+                          <a:solidFill>
+                            <a:srgbClr val="2B332C"/>
+                          </a:solidFill>
+                          <a:latin typeface="Calibri" pitchFamily="34" charset="0"/>
+                          <a:ea typeface="Calibri" pitchFamily="34" charset="-122"/>
+                          <a:cs typeface="Calibri" pitchFamily="34" charset="-120"/>
+                        </a:rPr>
+                        <a:t>De </a:t>
+                      </a:r>
+                      <a:r>
                         <a:rPr lang="en-US" sz="1050" dirty="0">
                           <a:solidFill>
                             <a:srgbClr val="2B332C"/>
@@ -10270,7 +9748,7 @@
                           <a:ea typeface="Calibri" pitchFamily="34" charset="-122"/>
                           <a:cs typeface="Calibri" pitchFamily="34" charset="-120"/>
                         </a:rPr>
-                        <a:t>De conclusão. Nenhum país acumula volume para dizer o que funciona, e a leitura se </a:t>
+                        <a:t>conclusão. Nenhum país acumula volume para dizer o que funciona, e a leitura se </a:t>
                       </a:r>
                       <a:r>
                         <a:rPr lang="en-US" sz="1050" dirty="0" err="1" smtClean="0">
@@ -10573,7 +10051,29 @@
                           <a:ea typeface="Calibri" pitchFamily="34" charset="-122"/>
                           <a:cs typeface="Calibri" pitchFamily="34" charset="-120"/>
                         </a:rPr>
-                        <a:t>Leads reais e leitura por país. Foi este caminho que produziu os 40 leads de julho.</a:t>
+                        <a:t>Leads reais e leitura por país. Foi este caminho que produziu os 49 leads de </a:t>
+                      </a:r>
+                      <a:r>
+                        <a:rPr lang="en-US" sz="1050" dirty="0" err="1">
+                          <a:solidFill>
+                            <a:srgbClr val="2B332C"/>
+                          </a:solidFill>
+                          <a:latin typeface="Calibri" pitchFamily="34" charset="0"/>
+                          <a:ea typeface="Calibri" pitchFamily="34" charset="-122"/>
+                          <a:cs typeface="Calibri" pitchFamily="34" charset="-120"/>
+                        </a:rPr>
+                        <a:t>julho</a:t>
+                      </a:r>
+                      <a:r>
+                        <a:rPr lang="en-US" sz="1050" dirty="0" smtClean="0">
+                          <a:solidFill>
+                            <a:srgbClr val="2B332C"/>
+                          </a:solidFill>
+                          <a:latin typeface="Calibri" pitchFamily="34" charset="0"/>
+                          <a:ea typeface="Calibri" pitchFamily="34" charset="-122"/>
+                          <a:cs typeface="Calibri" pitchFamily="34" charset="-120"/>
+                        </a:rPr>
+                        <a:t>. </a:t>
                       </a:r>
                       <a:endParaRPr lang="en-US" sz="1050" dirty="0">
                         <a:latin typeface="Calibri" charset="0"/>
@@ -10902,7 +10402,7 @@
                           <a:ea typeface="Calibri" pitchFamily="34" charset="-122"/>
                           <a:cs typeface="Calibri" pitchFamily="34" charset="-120"/>
                         </a:rPr>
-                        <a:t>Da Alemanha e dos demais mercados nesta fase. Eles voltam quando os EUA se provarem ou com verba adicional.</a:t>
+                        <a:t>Da Alemanha e dos demais mercados nesta fase. A Alemanha consumiu 26% do Google para 9% dos cliques e 42% do Meta para 14% dos leads. Eles voltam quando os EUA se provarem ou com verba adicional.</a:t>
                       </a:r>
                       <a:endParaRPr lang="en-US" sz="1050" dirty="0">
                         <a:latin typeface="Calibri" charset="0"/>
@@ -10984,6 +10484,13 @@
             <a:prstDash val="solid"/>
           </a:ln>
         </p:spPr>
+        <p:txBody>
+          <a:bodyPr/>
+          <a:lstStyle/>
+          <a:p>
+            <a:endParaRPr/>
+          </a:p>
+        </p:txBody>
       </p:sp>
       <p:sp>
         <p:nvSpPr>
@@ -11416,6 +10923,13 @@
             <a:prstDash val="solid"/>
           </a:ln>
         </p:spPr>
+        <p:txBody>
+          <a:bodyPr/>
+          <a:lstStyle/>
+          <a:p>
+            <a:endParaRPr/>
+          </a:p>
+        </p:txBody>
       </p:sp>
       <p:sp>
         <p:nvSpPr>
@@ -11453,51 +10967,7 @@
                 <a:ea typeface="Calibri" pitchFamily="34" charset="-122"/>
                 <a:cs typeface="Calibri" pitchFamily="34" charset="-120"/>
               </a:rPr>
-              <a:t>Exemplo</a:t>
-            </a:r>
-            <a:r>
-              <a:rPr lang="en-US" sz="1100" b="1" dirty="0">
-                <a:solidFill>
-                  <a:srgbClr val="B8C037"/>
-                </a:solidFill>
-                <a:latin typeface="Calibri" pitchFamily="34" charset="0"/>
-                <a:ea typeface="Calibri" pitchFamily="34" charset="-122"/>
-                <a:cs typeface="Calibri" pitchFamily="34" charset="-120"/>
-              </a:rPr>
-              <a:t> </a:t>
-            </a:r>
-            <a:r>
-              <a:rPr lang="en-US" sz="1100" b="1" dirty="0" err="1" smtClean="0">
-                <a:solidFill>
-                  <a:srgbClr val="B8C037"/>
-                </a:solidFill>
-                <a:latin typeface="Calibri" pitchFamily="34" charset="0"/>
-                <a:ea typeface="Calibri" pitchFamily="34" charset="-122"/>
-                <a:cs typeface="Calibri" pitchFamily="34" charset="-120"/>
-              </a:rPr>
-              <a:t>concreto</a:t>
-            </a:r>
-            <a:r>
-              <a:rPr lang="en-US" sz="1100" b="1" dirty="0" smtClean="0">
-                <a:solidFill>
-                  <a:srgbClr val="B8C037"/>
-                </a:solidFill>
-                <a:latin typeface="Calibri" pitchFamily="34" charset="0"/>
-                <a:ea typeface="Calibri" pitchFamily="34" charset="-122"/>
-                <a:cs typeface="Calibri" pitchFamily="34" charset="-120"/>
-              </a:rPr>
-              <a:t>:  </a:t>
-            </a:r>
-            <a:r>
-              <a:rPr lang="en-US" sz="1100" dirty="0">
-                <a:solidFill>
-                  <a:srgbClr val="DDE3DB"/>
-                </a:solidFill>
-                <a:latin typeface="Calibri" pitchFamily="34" charset="0"/>
-                <a:ea typeface="Calibri" pitchFamily="34" charset="-122"/>
-                <a:cs typeface="Calibri" pitchFamily="34" charset="-120"/>
-              </a:rPr>
-              <a:t>Nos EUA, em 23% das buscas relevantes a campanha nem chega a disputar o leilão, por limite de orçamento. Não é só qualidade de anúncio: é verba disponível e tempo de aprendizado acumulado. Concentrar acelera os dois.</a:t>
+              <a:t>Exemplo concreto:  Nos EUA, em 18% das buscas relevantes a campanha nem chega a disputar o leilão, por limite de orçamento. Na Alemanha esse número é 57%. Não é só qualidade de anúncio: é verba disponível e tempo de aprendizado. Concentrar acelera os dois.</a:t>
             </a:r>
             <a:endParaRPr lang="en-US" sz="1100" dirty="0"/>
           </a:p>
@@ -12279,6 +11749,13 @@
             <a:prstDash val="solid"/>
           </a:ln>
         </p:spPr>
+        <p:txBody>
+          <a:bodyPr/>
+          <a:lstStyle/>
+          <a:p>
+            <a:endParaRPr/>
+          </a:p>
+        </p:txBody>
       </p:sp>
       <p:sp>
         <p:nvSpPr>
@@ -12352,7 +11829,7 @@
                 <a:ea typeface="Arial" pitchFamily="34" charset="-122"/>
                 <a:cs typeface="Arial" pitchFamily="34" charset="-120"/>
               </a:rPr>
-              <a:t>Concluir a instrumentação de rastreamento</a:t>
+              <a:t>Rastreamento do Google concluído</a:t>
             </a:r>
             <a:endParaRPr lang="en-US" sz="1500" dirty="0"/>
           </a:p>
@@ -12383,6 +11860,17 @@
               <a:buNone/>
             </a:pPr>
             <a:r>
+              <a:rPr lang="en-US" sz="1150" b="1" i="1" dirty="0">
+                <a:solidFill>
+                  <a:srgbClr val="AFC0AE"/>
+                </a:solidFill>
+                <a:latin typeface="Calibri" pitchFamily="34" charset="0"/>
+                <a:ea typeface="Calibri" pitchFamily="34" charset="-122"/>
+                <a:cs typeface="Calibri" pitchFamily="34" charset="-120"/>
+              </a:rPr>
+              <a:t>generate_lead</a:t>
+            </a:r>
+            <a:r>
               <a:rPr lang="en-US" sz="1150" dirty="0">
                 <a:solidFill>
                   <a:srgbClr val="AFC0AE"/>
@@ -12391,7 +11879,7 @@
                 <a:ea typeface="Calibri" pitchFamily="34" charset="-122"/>
                 <a:cs typeface="Calibri" pitchFamily="34" charset="-120"/>
               </a:rPr>
-              <a:t>Tag de conversão no Google e pixel na página: otimização automática e retargeting</a:t>
+              <a:t> ativo como conversão principal desde 16/07. Pixel do Meta na página segue adiado por conflito no contêiner de tags e não impede captar lead</a:t>
             </a:r>
             <a:endParaRPr lang="en-US" sz="1150" dirty="0"/>
           </a:p>
@@ -12421,6 +11909,13 @@
             <a:prstDash val="solid"/>
           </a:ln>
         </p:spPr>
+        <p:txBody>
+          <a:bodyPr/>
+          <a:lstStyle/>
+          <a:p>
+            <a:endParaRPr/>
+          </a:p>
+        </p:txBody>
       </p:sp>
       <p:sp>
         <p:nvSpPr>
@@ -12494,7 +11989,7 @@
                 <a:ea typeface="Arial" pitchFamily="34" charset="-122"/>
                 <a:cs typeface="Arial" pitchFamily="34" charset="-120"/>
               </a:rPr>
-              <a:t>Medir o formulário V3 por 14 dias</a:t>
+              <a:t>Escalar o V3 em agosto</a:t>
             </a:r>
             <a:endParaRPr lang="en-US" sz="1500" dirty="0"/>
           </a:p>
@@ -12533,7 +12028,7 @@
                 <a:ea typeface="Calibri" pitchFamily="34" charset="-122"/>
                 <a:cs typeface="Calibri" pitchFamily="34" charset="-120"/>
               </a:rPr>
-              <a:t>Validar se o perfil sobe quando o volume cai</a:t>
+              <a:t>Julho fecha em R$ 50/dia no Meta e R$ 70/dia no Google para respeitar o teto do mês. Em agosto o formulário fica congelado e a verba volta ao patamar que gerou a série</a:t>
             </a:r>
             <a:endParaRPr lang="en-US" sz="1150" dirty="0"/>
           </a:p>
@@ -12563,6 +12058,13 @@
             <a:prstDash val="solid"/>
           </a:ln>
         </p:spPr>
+        <p:txBody>
+          <a:bodyPr/>
+          <a:lstStyle/>
+          <a:p>
+            <a:endParaRPr/>
+          </a:p>
+        </p:txBody>
       </p:sp>
       <p:sp>
         <p:nvSpPr>
@@ -12727,6 +12229,13 @@
             <a:prstDash val="solid"/>
           </a:ln>
         </p:spPr>
+        <p:txBody>
+          <a:bodyPr/>
+          <a:lstStyle/>
+          <a:p>
+            <a:endParaRPr/>
+          </a:p>
+        </p:txBody>
       </p:sp>
       <p:sp>
         <p:nvSpPr>
@@ -12871,6 +12380,13 @@
             <a:prstDash val="solid"/>
           </a:ln>
         </p:spPr>
+        <p:txBody>
+          <a:bodyPr/>
+          <a:lstStyle/>
+          <a:p>
+            <a:endParaRPr/>
+          </a:p>
+        </p:txBody>
       </p:sp>
       <p:sp>
         <p:nvSpPr>
@@ -13118,6 +12634,13 @@
             <a:prstDash val="solid"/>
           </a:ln>
         </p:spPr>
+        <p:txBody>
+          <a:bodyPr/>
+          <a:lstStyle/>
+          <a:p>
+            <a:endParaRPr/>
+          </a:p>
+        </p:txBody>
       </p:sp>
       <p:sp>
         <p:nvSpPr>
@@ -13279,84 +12802,7 @@
                 <a:ea typeface="Calibri" pitchFamily="34" charset="-122"/>
                 <a:cs typeface="Calibri" pitchFamily="34" charset="-120"/>
               </a:rPr>
-              <a:t>Próxima</a:t>
-            </a:r>
-            <a:r>
-              <a:rPr lang="en-US" sz="900" i="1" dirty="0">
-                <a:solidFill>
-                  <a:srgbClr val="6E7B70"/>
-                </a:solidFill>
-                <a:latin typeface="Calibri" pitchFamily="34" charset="0"/>
-                <a:ea typeface="Calibri" pitchFamily="34" charset="-122"/>
-                <a:cs typeface="Calibri" pitchFamily="34" charset="-120"/>
-              </a:rPr>
-              <a:t> </a:t>
-            </a:r>
-            <a:r>
-              <a:rPr lang="en-US" sz="900" i="1" dirty="0" err="1" smtClean="0">
-                <a:solidFill>
-                  <a:srgbClr val="6E7B70"/>
-                </a:solidFill>
-                <a:latin typeface="Calibri" pitchFamily="34" charset="0"/>
-                <a:ea typeface="Calibri" pitchFamily="34" charset="-122"/>
-                <a:cs typeface="Calibri" pitchFamily="34" charset="-120"/>
-              </a:rPr>
-              <a:t>revisão</a:t>
-            </a:r>
-            <a:r>
-              <a:rPr lang="en-US" sz="900" i="1" dirty="0">
-                <a:solidFill>
-                  <a:srgbClr val="6E7B70"/>
-                </a:solidFill>
-                <a:latin typeface="Calibri" pitchFamily="34" charset="0"/>
-                <a:ea typeface="Calibri" pitchFamily="34" charset="-122"/>
-                <a:cs typeface="Calibri" pitchFamily="34" charset="-120"/>
-              </a:rPr>
-              <a:t> </a:t>
-            </a:r>
-            <a:r>
-              <a:rPr lang="en-US" sz="900" i="1" dirty="0" smtClean="0">
-                <a:solidFill>
-                  <a:srgbClr val="6E7B70"/>
-                </a:solidFill>
-                <a:latin typeface="Calibri" pitchFamily="34" charset="0"/>
-                <a:ea typeface="Calibri" pitchFamily="34" charset="-122"/>
-                <a:cs typeface="Calibri" pitchFamily="34" charset="-120"/>
-              </a:rPr>
-              <a:t>no </a:t>
-            </a:r>
-            <a:r>
-              <a:rPr lang="en-US" sz="900" i="1" dirty="0" err="1" smtClean="0">
-                <a:solidFill>
-                  <a:srgbClr val="6E7B70"/>
-                </a:solidFill>
-                <a:latin typeface="Calibri" pitchFamily="34" charset="0"/>
-                <a:ea typeface="Calibri" pitchFamily="34" charset="-122"/>
-                <a:cs typeface="Calibri" pitchFamily="34" charset="-120"/>
-              </a:rPr>
-              <a:t>início</a:t>
-            </a:r>
-            <a:r>
-              <a:rPr lang="en-US" sz="900" i="1" dirty="0" smtClean="0">
-                <a:solidFill>
-                  <a:srgbClr val="6E7B70"/>
-                </a:solidFill>
-                <a:latin typeface="Calibri" pitchFamily="34" charset="0"/>
-                <a:ea typeface="Calibri" pitchFamily="34" charset="-122"/>
-                <a:cs typeface="Calibri" pitchFamily="34" charset="-120"/>
-              </a:rPr>
-              <a:t> de Agosto de </a:t>
-            </a:r>
-            <a:r>
-              <a:rPr lang="en-US" sz="900" i="1" dirty="0">
-                <a:solidFill>
-                  <a:srgbClr val="6E7B70"/>
-                </a:solidFill>
-                <a:latin typeface="Calibri" pitchFamily="34" charset="0"/>
-                <a:ea typeface="Calibri" pitchFamily="34" charset="-122"/>
-                <a:cs typeface="Calibri" pitchFamily="34" charset="-120"/>
-              </a:rPr>
-              <a:t>2026, com os primeiros dados do formulário V3 e do rastreamento completo.</a:t>
+              <a:t>Próxima revisão no início de setembro de 2026, com o primeiro mês fechado inteiramente sob o formulário V3.</a:t>
             </a:r>
             <a:endParaRPr lang="en-US" sz="900" dirty="0"/>
           </a:p>

</xml_diff>